<commit_message>
Quiet solver output checks and status probing
</commit_message>
<xml_diff>
--- a/outputs/autofluid_project_architecture.pptx
+++ b/outputs/autofluid_project_architecture.pptx
@@ -703,7 +703,7 @@
         </p:nvSpPr>
         <p:spPr>
           <a:xfrm>
-            <a:off x="4091305" y="1524000"/>
+            <a:off x="4130040" y="1524000"/>
             <a:ext cx="3714750" cy="6169660"/>
           </a:xfrm>
           <a:prstGeom prst="roundRect">
@@ -744,7 +744,7 @@
         </p:nvSpPr>
         <p:spPr>
           <a:xfrm>
-            <a:off x="8286750" y="1524000"/>
+            <a:off x="8248015" y="1524000"/>
             <a:ext cx="6534150" cy="6169660"/>
           </a:xfrm>
           <a:prstGeom prst="roundRect">
@@ -950,20 +950,23 @@
         </p:nvSpPr>
         <p:spPr>
           <a:xfrm>
-            <a:off x="4914900" y="253365"/>
-            <a:ext cx="2076450" cy="647700"/>
+            <a:off x="4965700" y="109855"/>
+            <a:ext cx="1974850" cy="1115695"/>
           </a:xfrm>
           <a:prstGeom prst="roundRect">
             <a:avLst>
-              <a:gd name="adj" fmla="val 26471"/>
+              <a:gd name="adj" fmla="val 11838"/>
             </a:avLst>
           </a:prstGeom>
           <a:solidFill>
-            <a:srgbClr val="FFF4DB"/>
+            <a:srgbClr val="FCFCFC"/>
           </a:solidFill>
           <a:ln w="13335">
             <a:solidFill>
-              <a:srgbClr val="F1C375"/>
+              <a:schemeClr val="accent5">
+                <a:lumMod val="60000"/>
+                <a:lumOff val="40000"/>
+              </a:schemeClr>
             </a:solidFill>
             <a:prstDash val="solid"/>
           </a:ln>
@@ -994,7 +997,7 @@
             <a:r>
               <a:rPr sz="1500" b="1">
                 <a:solidFill>
-                  <a:srgbClr val="B45309"/>
+                  <a:srgbClr val="ED98E6"/>
                 </a:solidFill>
                 <a:latin typeface="HarmonyOS Sans SC" panose="00000500000000000000" charset="-122"/>
                 <a:ea typeface="HarmonyOS Sans SC" panose="00000500000000000000" charset="-122"/>
@@ -1004,35 +1007,7 @@
             </a:r>
             <a:endParaRPr sz="1500" b="1">
               <a:solidFill>
-                <a:srgbClr val="B45309"/>
-              </a:solidFill>
-              <a:latin typeface="HarmonyOS Sans SC" panose="00000500000000000000" charset="-122"/>
-              <a:ea typeface="HarmonyOS Sans SC" panose="00000500000000000000" charset="-122"/>
-              <a:cs typeface="HarmonyOS Sans SC" panose="00000500000000000000" charset="-122"/>
-            </a:endParaRPr>
-          </a:p>
-          <a:p>
-            <a:pPr algn="ctr">
-              <a:defRPr sz="1500" b="1">
-                <a:solidFill>
-                  <a:srgbClr val="B45309"/>
-                </a:solidFill>
-              </a:defRPr>
-            </a:pPr>
-            <a:r>
-              <a:rPr sz="1500" b="1">
-                <a:solidFill>
-                  <a:srgbClr val="B45309"/>
-                </a:solidFill>
-                <a:latin typeface="HarmonyOS Sans SC" panose="00000500000000000000" charset="-122"/>
-                <a:ea typeface="HarmonyOS Sans SC" panose="00000500000000000000" charset="-122"/>
-                <a:cs typeface="HarmonyOS Sans SC" panose="00000500000000000000" charset="-122"/>
-              </a:rPr>
-              <a:t>QQ / 微信</a:t>
-            </a:r>
-            <a:endParaRPr sz="1500" b="1">
-              <a:solidFill>
-                <a:srgbClr val="B45309"/>
+                <a:srgbClr val="ED98E6"/>
               </a:solidFill>
               <a:latin typeface="HarmonyOS Sans SC" panose="00000500000000000000" charset="-122"/>
               <a:ea typeface="HarmonyOS Sans SC" panose="00000500000000000000" charset="-122"/>
@@ -1121,7 +1096,7 @@
               </a:defRPr>
             </a:pPr>
             <a:r>
-              <a:rPr sz="1725" b="1">
+              <a:rPr lang="en-US" sz="1725" b="1">
                 <a:solidFill>
                   <a:srgbClr val="2563EB"/>
                 </a:solidFill>
@@ -1129,122 +1104,22 @@
                 <a:ea typeface="HarmonyOS Sans SC" panose="00000500000000000000" charset="-122"/>
                 <a:cs typeface="HarmonyOS Sans SC" panose="00000500000000000000" charset="-122"/>
               </a:rPr>
-              <a:t>Rust TUI / IPC Client</a:t>
-            </a:r>
-            <a:endParaRPr sz="1725" b="1">
+              <a:t>AutoF</a:t>
+            </a:r>
+            <a:r>
+              <a:rPr lang="en-US" sz="1725" b="1">
+                <a:solidFill>
+                  <a:srgbClr val="2563EB"/>
+                </a:solidFill>
+                <a:latin typeface="HarmonyOS Sans SC" panose="00000500000000000000" charset="-122"/>
+                <a:ea typeface="HarmonyOS Sans SC" panose="00000500000000000000" charset="-122"/>
+                <a:cs typeface="HarmonyOS Sans SC" panose="00000500000000000000" charset="-122"/>
+              </a:rPr>
+              <a:t>luid TUI</a:t>
+            </a:r>
+            <a:endParaRPr lang="en-US" sz="1725" b="1">
               <a:solidFill>
                 <a:srgbClr val="2563EB"/>
-              </a:solidFill>
-              <a:latin typeface="HarmonyOS Sans SC" panose="00000500000000000000" charset="-122"/>
-              <a:ea typeface="HarmonyOS Sans SC" panose="00000500000000000000" charset="-122"/>
-              <a:cs typeface="HarmonyOS Sans SC" panose="00000500000000000000" charset="-122"/>
-            </a:endParaRPr>
-          </a:p>
-        </p:txBody>
-      </p:sp>
-      <p:sp>
-        <p:nvSpPr>
-          <p:cNvPr id="12" name="frontend-body"/>
-          <p:cNvSpPr>
-            <a:spLocks noGrp="1"/>
-          </p:cNvSpPr>
-          <p:nvPr/>
-        </p:nvSpPr>
-        <p:spPr>
-          <a:xfrm>
-            <a:off x="952500" y="2952750"/>
-            <a:ext cx="2228850" cy="800100"/>
-          </a:xfrm>
-          <a:prstGeom prst="rect">
-            <a:avLst/>
-          </a:prstGeom>
-          <a:noFill/>
-          <a:ln w="0">
-            <a:noFill/>
-            <a:prstDash val="solid"/>
-          </a:ln>
-        </p:spPr>
-        <p:txBody>
-          <a:bodyPr anchor="ctr" anchorCtr="0"/>
-          <a:lstStyle/>
-          <a:p>
-            <a:pPr algn="ctr">
-              <a:defRPr sz="1275" b="0">
-                <a:solidFill>
-                  <a:srgbClr val="172033"/>
-                </a:solidFill>
-              </a:defRPr>
-            </a:pPr>
-            <a:r>
-              <a:rPr sz="1275" b="0">
-                <a:solidFill>
-                  <a:srgbClr val="172033"/>
-                </a:solidFill>
-                <a:latin typeface="HarmonyOS Sans SC" panose="00000500000000000000" charset="-122"/>
-                <a:ea typeface="HarmonyOS Sans SC" panose="00000500000000000000" charset="-122"/>
-                <a:cs typeface="HarmonyOS Sans SC" panose="00000500000000000000" charset="-122"/>
-              </a:rPr>
-              <a:t>启动 / 暂停 / 检查</a:t>
-            </a:r>
-            <a:endParaRPr sz="1275" b="0">
-              <a:solidFill>
-                <a:srgbClr val="172033"/>
-              </a:solidFill>
-              <a:latin typeface="HarmonyOS Sans SC" panose="00000500000000000000" charset="-122"/>
-              <a:ea typeface="HarmonyOS Sans SC" panose="00000500000000000000" charset="-122"/>
-              <a:cs typeface="HarmonyOS Sans SC" panose="00000500000000000000" charset="-122"/>
-            </a:endParaRPr>
-          </a:p>
-          <a:p>
-            <a:pPr algn="ctr">
-              <a:defRPr sz="1275" b="0">
-                <a:solidFill>
-                  <a:srgbClr val="172033"/>
-                </a:solidFill>
-              </a:defRPr>
-            </a:pPr>
-            <a:r>
-              <a:rPr sz="1275" b="0">
-                <a:solidFill>
-                  <a:srgbClr val="172033"/>
-                </a:solidFill>
-                <a:latin typeface="HarmonyOS Sans SC" panose="00000500000000000000" charset="-122"/>
-                <a:ea typeface="HarmonyOS Sans SC" panose="00000500000000000000" charset="-122"/>
-                <a:cs typeface="HarmonyOS Sans SC" panose="00000500000000000000" charset="-122"/>
-              </a:rPr>
-              <a:t>状态查看 / 日志查看</a:t>
-            </a:r>
-            <a:endParaRPr sz="1275" b="0">
-              <a:solidFill>
-                <a:srgbClr val="172033"/>
-              </a:solidFill>
-              <a:latin typeface="HarmonyOS Sans SC" panose="00000500000000000000" charset="-122"/>
-              <a:ea typeface="HarmonyOS Sans SC" panose="00000500000000000000" charset="-122"/>
-              <a:cs typeface="HarmonyOS Sans SC" panose="00000500000000000000" charset="-122"/>
-            </a:endParaRPr>
-          </a:p>
-          <a:p>
-            <a:pPr algn="ctr">
-              <a:defRPr sz="1275" b="0">
-                <a:solidFill>
-                  <a:srgbClr val="172033"/>
-                </a:solidFill>
-              </a:defRPr>
-            </a:pPr>
-            <a:r>
-              <a:rPr sz="1275" b="0">
-                <a:solidFill>
-                  <a:srgbClr val="172033"/>
-                </a:solidFill>
-                <a:latin typeface="HarmonyOS Sans SC" panose="00000500000000000000" charset="-122"/>
-                <a:ea typeface="HarmonyOS Sans SC" panose="00000500000000000000" charset="-122"/>
-                <a:cs typeface="HarmonyOS Sans SC" panose="00000500000000000000" charset="-122"/>
-              </a:rPr>
-              <a:t>设置编辑 / IPC 访问</a:t>
-            </a:r>
-            <a:endParaRPr sz="1275" b="0">
-              <a:solidFill>
-                <a:srgbClr val="172033"/>
               </a:solidFill>
               <a:latin typeface="HarmonyOS Sans SC" panose="00000500000000000000" charset="-122"/>
               <a:ea typeface="HarmonyOS Sans SC" panose="00000500000000000000" charset="-122"/>
@@ -1334,7 +1209,7 @@
         </p:nvSpPr>
         <p:spPr>
           <a:xfrm>
-            <a:off x="971550" y="4972050"/>
+            <a:off x="971550" y="4888230"/>
             <a:ext cx="2190750" cy="304800"/>
           </a:xfrm>
           <a:prstGeom prst="roundRect">
@@ -1372,7 +1247,29 @@
                 <a:ea typeface="HarmonyOS Sans SC" panose="00000500000000000000" charset="-122"/>
                 <a:cs typeface="HarmonyOS Sans SC" panose="00000500000000000000" charset="-122"/>
               </a:rPr>
-              <a:t>本地 worker</a:t>
+              <a:t>本地 </a:t>
+            </a:r>
+            <a:r>
+              <a:rPr lang="en-US" sz="1125" b="0">
+                <a:solidFill>
+                  <a:srgbClr val="172033"/>
+                </a:solidFill>
+                <a:latin typeface="HarmonyOS Sans SC" panose="00000500000000000000" charset="-122"/>
+                <a:ea typeface="HarmonyOS Sans SC" panose="00000500000000000000" charset="-122"/>
+                <a:cs typeface="HarmonyOS Sans SC" panose="00000500000000000000" charset="-122"/>
+              </a:rPr>
+              <a:t>W</a:t>
+            </a:r>
+            <a:r>
+              <a:rPr sz="1125" b="0">
+                <a:solidFill>
+                  <a:srgbClr val="172033"/>
+                </a:solidFill>
+                <a:latin typeface="HarmonyOS Sans SC" panose="00000500000000000000" charset="-122"/>
+                <a:ea typeface="HarmonyOS Sans SC" panose="00000500000000000000" charset="-122"/>
+                <a:cs typeface="HarmonyOS Sans SC" panose="00000500000000000000" charset="-122"/>
+              </a:rPr>
+              <a:t>orker</a:t>
             </a:r>
             <a:endParaRPr sz="1125" b="0">
               <a:solidFill>
@@ -1395,7 +1292,7 @@
         </p:nvSpPr>
         <p:spPr>
           <a:xfrm>
-            <a:off x="2126615" y="6143625"/>
+            <a:off x="995045" y="6059805"/>
             <a:ext cx="1035685" cy="304800"/>
           </a:xfrm>
           <a:prstGeom prst="roundRect">
@@ -1454,7 +1351,7 @@
         </p:nvSpPr>
         <p:spPr>
           <a:xfrm>
-            <a:off x="971550" y="5443855"/>
+            <a:off x="2126615" y="5360035"/>
             <a:ext cx="1035685" cy="533400"/>
           </a:xfrm>
           <a:prstGeom prst="roundRect">
@@ -1562,73 +1459,6 @@
                 </a:solidFill>
               </a:defRPr>
             </a:pPr>
-            <a:r>
-              <a:rPr sz="1200" b="0">
-                <a:solidFill>
-                  <a:srgbClr val="172033"/>
-                </a:solidFill>
-                <a:latin typeface="HarmonyOS Sans SC" panose="00000500000000000000" charset="-122"/>
-                <a:ea typeface="HarmonyOS Sans SC" panose="00000500000000000000" charset="-122"/>
-                <a:cs typeface="HarmonyOS Sans SC" panose="00000500000000000000" charset="-122"/>
-              </a:rPr>
-              <a:t>Windows-only 建模转换</a:t>
-            </a:r>
-            <a:endParaRPr sz="1200" b="0">
-              <a:solidFill>
-                <a:srgbClr val="172033"/>
-              </a:solidFill>
-              <a:latin typeface="HarmonyOS Sans SC" panose="00000500000000000000" charset="-122"/>
-              <a:ea typeface="HarmonyOS Sans SC" panose="00000500000000000000" charset="-122"/>
-              <a:cs typeface="HarmonyOS Sans SC" panose="00000500000000000000" charset="-122"/>
-            </a:endParaRPr>
-          </a:p>
-          <a:p>
-            <a:pPr algn="ctr">
-              <a:defRPr sz="1200" b="0">
-                <a:solidFill>
-                  <a:srgbClr val="172033"/>
-                </a:solidFill>
-              </a:defRPr>
-            </a:pPr>
-            <a:r>
-              <a:rPr sz="1200" b="0">
-                <a:solidFill>
-                  <a:srgbClr val="172033"/>
-                </a:solidFill>
-                <a:latin typeface="HarmonyOS Sans SC" panose="00000500000000000000" charset="-122"/>
-                <a:ea typeface="HarmonyOS Sans SC" panose="00000500000000000000" charset="-122"/>
-                <a:cs typeface="HarmonyOS Sans SC" panose="00000500000000000000" charset="-122"/>
-              </a:rPr>
-              <a:t>注册 / 心跳 / 轮询任务</a:t>
-            </a:r>
-            <a:endParaRPr sz="1200" b="0">
-              <a:solidFill>
-                <a:srgbClr val="172033"/>
-              </a:solidFill>
-              <a:latin typeface="HarmonyOS Sans SC" panose="00000500000000000000" charset="-122"/>
-              <a:ea typeface="HarmonyOS Sans SC" panose="00000500000000000000" charset="-122"/>
-              <a:cs typeface="HarmonyOS Sans SC" panose="00000500000000000000" charset="-122"/>
-            </a:endParaRPr>
-          </a:p>
-          <a:p>
-            <a:pPr algn="ctr">
-              <a:defRPr sz="1200" b="0">
-                <a:solidFill>
-                  <a:srgbClr val="172033"/>
-                </a:solidFill>
-              </a:defRPr>
-            </a:pPr>
-            <a:r>
-              <a:rPr sz="1200" b="0">
-                <a:solidFill>
-                  <a:srgbClr val="172033"/>
-                </a:solidFill>
-                <a:latin typeface="HarmonyOS Sans SC" panose="00000500000000000000" charset="-122"/>
-                <a:ea typeface="HarmonyOS Sans SC" panose="00000500000000000000" charset="-122"/>
-                <a:cs typeface="HarmonyOS Sans SC" panose="00000500000000000000" charset="-122"/>
-              </a:rPr>
-              <a:t>完成后上传 SCDOC</a:t>
-            </a:r>
             <a:endParaRPr sz="1200" b="0">
               <a:solidFill>
                 <a:srgbClr val="172033"/>
@@ -1650,8 +1480,8 @@
         </p:nvSpPr>
         <p:spPr>
           <a:xfrm>
-            <a:off x="4610100" y="2114550"/>
-            <a:ext cx="2686050" cy="723900"/>
+            <a:off x="4434205" y="2114550"/>
+            <a:ext cx="1493520" cy="723900"/>
           </a:xfrm>
           <a:prstGeom prst="roundRect">
             <a:avLst>
@@ -1692,7 +1522,7 @@
               </a:defRPr>
             </a:pPr>
             <a:r>
-              <a:rPr sz="1500" b="1">
+              <a:rPr sz="1200" b="1">
                 <a:solidFill>
                   <a:srgbClr val="B45309"/>
                 </a:solidFill>
@@ -1702,7 +1532,7 @@
               </a:rPr>
               <a:t>OpenClaw</a:t>
             </a:r>
-            <a:endParaRPr sz="1500" b="1">
+            <a:endParaRPr sz="1200" b="1">
               <a:solidFill>
                 <a:srgbClr val="B45309"/>
               </a:solidFill>
@@ -1720,7 +1550,7 @@
               </a:defRPr>
             </a:pPr>
             <a:r>
-              <a:rPr sz="1500" b="1">
+              <a:rPr sz="1200" b="1">
                 <a:solidFill>
                   <a:srgbClr val="B45309"/>
                 </a:solidFill>
@@ -1728,9 +1558,37 @@
                 <a:ea typeface="HarmonyOS Sans SC" panose="00000500000000000000" charset="-122"/>
                 <a:cs typeface="HarmonyOS Sans SC" panose="00000500000000000000" charset="-122"/>
               </a:rPr>
-              <a:t>通知网关 / 会话路由</a:t>
-            </a:r>
-            <a:endParaRPr sz="1500" b="1">
+              <a:t>通知网关</a:t>
+            </a:r>
+            <a:endParaRPr sz="1200" b="1">
+              <a:solidFill>
+                <a:srgbClr val="B45309"/>
+              </a:solidFill>
+              <a:latin typeface="HarmonyOS Sans SC" panose="00000500000000000000" charset="-122"/>
+              <a:ea typeface="HarmonyOS Sans SC" panose="00000500000000000000" charset="-122"/>
+              <a:cs typeface="HarmonyOS Sans SC" panose="00000500000000000000" charset="-122"/>
+            </a:endParaRPr>
+          </a:p>
+          <a:p>
+            <a:pPr algn="ctr">
+              <a:defRPr sz="1500" b="1">
+                <a:solidFill>
+                  <a:srgbClr val="B45309"/>
+                </a:solidFill>
+              </a:defRPr>
+            </a:pPr>
+            <a:r>
+              <a:rPr sz="1200" b="1">
+                <a:solidFill>
+                  <a:srgbClr val="B45309"/>
+                </a:solidFill>
+                <a:latin typeface="HarmonyOS Sans SC" panose="00000500000000000000" charset="-122"/>
+                <a:ea typeface="HarmonyOS Sans SC" panose="00000500000000000000" charset="-122"/>
+                <a:cs typeface="HarmonyOS Sans SC" panose="00000500000000000000" charset="-122"/>
+              </a:rPr>
+              <a:t>会话路由</a:t>
+            </a:r>
+            <a:endParaRPr sz="1200" b="1">
               <a:solidFill>
                 <a:srgbClr val="B45309"/>
               </a:solidFill>
@@ -1751,8 +1609,8 @@
         </p:nvSpPr>
         <p:spPr>
           <a:xfrm>
-            <a:off x="4610100" y="3105150"/>
-            <a:ext cx="2686050" cy="723900"/>
+            <a:off x="4434205" y="3105150"/>
+            <a:ext cx="1493520" cy="723900"/>
           </a:xfrm>
           <a:prstGeom prst="roundRect">
             <a:avLst>
@@ -1793,7 +1651,7 @@
               </a:defRPr>
             </a:pPr>
             <a:r>
-              <a:rPr lang="en-US" sz="1500" b="1">
+              <a:rPr lang="en-US" sz="1200" b="1">
                 <a:solidFill>
                   <a:srgbClr val="C2410C"/>
                 </a:solidFill>
@@ -1804,7 +1662,7 @@
               <a:t>A</a:t>
             </a:r>
             <a:r>
-              <a:rPr sz="1500" b="1">
+              <a:rPr sz="1200" b="1">
                 <a:solidFill>
                   <a:srgbClr val="C2410C"/>
                 </a:solidFill>
@@ -1814,7 +1672,7 @@
               </a:rPr>
               <a:t>lert watcher</a:t>
             </a:r>
-            <a:endParaRPr sz="1500" b="1">
+            <a:endParaRPr sz="1200" b="1">
               <a:solidFill>
                 <a:srgbClr val="C2410C"/>
               </a:solidFill>
@@ -1832,7 +1690,7 @@
               </a:defRPr>
             </a:pPr>
             <a:r>
-              <a:rPr sz="1500" b="1">
+              <a:rPr sz="1200" b="1">
                 <a:solidFill>
                   <a:srgbClr val="C2410C"/>
                 </a:solidFill>
@@ -1840,9 +1698,37 @@
                 <a:ea typeface="HarmonyOS Sans SC" panose="00000500000000000000" charset="-122"/>
                 <a:cs typeface="HarmonyOS Sans SC" panose="00000500000000000000" charset="-122"/>
               </a:rPr>
-              <a:t>拉取 WARNING+ 日志</a:t>
-            </a:r>
-            <a:endParaRPr sz="1500" b="1">
+              <a:t>拉取 WARNING+ </a:t>
+            </a:r>
+            <a:endParaRPr sz="1200" b="1">
+              <a:solidFill>
+                <a:srgbClr val="C2410C"/>
+              </a:solidFill>
+              <a:latin typeface="HarmonyOS Sans SC" panose="00000500000000000000" charset="-122"/>
+              <a:ea typeface="HarmonyOS Sans SC" panose="00000500000000000000" charset="-122"/>
+              <a:cs typeface="HarmonyOS Sans SC" panose="00000500000000000000" charset="-122"/>
+            </a:endParaRPr>
+          </a:p>
+          <a:p>
+            <a:pPr algn="ctr">
+              <a:defRPr sz="1500" b="1">
+                <a:solidFill>
+                  <a:srgbClr val="C2410C"/>
+                </a:solidFill>
+              </a:defRPr>
+            </a:pPr>
+            <a:r>
+              <a:rPr sz="1200" b="1">
+                <a:solidFill>
+                  <a:srgbClr val="C2410C"/>
+                </a:solidFill>
+                <a:latin typeface="HarmonyOS Sans SC" panose="00000500000000000000" charset="-122"/>
+                <a:ea typeface="HarmonyOS Sans SC" panose="00000500000000000000" charset="-122"/>
+                <a:cs typeface="HarmonyOS Sans SC" panose="00000500000000000000" charset="-122"/>
+              </a:rPr>
+              <a:t>日志</a:t>
+            </a:r>
+            <a:endParaRPr sz="1200" b="1">
               <a:solidFill>
                 <a:srgbClr val="C2410C"/>
               </a:solidFill>
@@ -5026,12 +4912,12 @@
         </p:nvSpPr>
         <p:spPr>
           <a:xfrm>
-            <a:off x="5891530" y="3853815"/>
+            <a:off x="4347845" y="3830955"/>
             <a:ext cx="1390650" cy="323850"/>
           </a:xfrm>
           <a:prstGeom prst="roundRect">
             <a:avLst>
-              <a:gd name="adj" fmla="val 23529"/>
+              <a:gd name="adj" fmla="val 0"/>
             </a:avLst>
           </a:prstGeom>
           <a:noFill/>
@@ -5050,12 +4936,12 @@
           </a:extLst>
         </p:spPr>
         <p:txBody>
-          <a:bodyPr>
+          <a:bodyPr anchor="ctr" anchorCtr="0">
             <a:noAutofit/>
           </a:bodyPr>
           <a:lstStyle/>
           <a:p>
-            <a:pPr lvl="0" algn="ctr">
+            <a:pPr lvl="0" algn="r">
               <a:buClrTx/>
               <a:buSzTx/>
               <a:buFontTx/>
@@ -5176,12 +5062,12 @@
         </p:nvSpPr>
         <p:spPr>
           <a:xfrm rot="5400000">
-            <a:off x="2912110" y="1933575"/>
+            <a:off x="2941320" y="1933575"/>
             <a:ext cx="1962150" cy="323850"/>
           </a:xfrm>
           <a:prstGeom prst="roundRect">
             <a:avLst>
-              <a:gd name="adj" fmla="val 23529"/>
+              <a:gd name="adj" fmla="val 0"/>
             </a:avLst>
           </a:prstGeom>
           <a:noFill/>
@@ -5200,7 +5086,7 @@
           </a:extLst>
         </p:spPr>
         <p:txBody>
-          <a:bodyPr/>
+          <a:bodyPr anchor="ctr" anchorCtr="0"/>
           <a:lstStyle/>
           <a:p>
             <a:pPr algn="r">
@@ -5211,6 +5097,17 @@
               </a:defRPr>
             </a:pPr>
             <a:r>
+              <a:rPr lang="zh-CN" sz="1050" b="1">
+                <a:solidFill>
+                  <a:srgbClr val="2563EB"/>
+                </a:solidFill>
+                <a:latin typeface="HarmonyOS Sans SC" panose="00000500000000000000" charset="-122"/>
+                <a:ea typeface="HarmonyOS Sans SC" panose="00000500000000000000" charset="-122"/>
+                <a:cs typeface="HarmonyOS Sans SC" panose="00000500000000000000" charset="-122"/>
+              </a:rPr>
+              <a:t>组件拉起</a:t>
+            </a:r>
+            <a:r>
               <a:rPr sz="1050" b="1">
                 <a:solidFill>
                   <a:srgbClr val="2563EB"/>
@@ -5219,9 +5116,31 @@
                 <a:ea typeface="HarmonyOS Sans SC" panose="00000500000000000000" charset="-122"/>
                 <a:cs typeface="HarmonyOS Sans SC" panose="00000500000000000000" charset="-122"/>
               </a:rPr>
-              <a:t>SSH 本地端口转发 / IPC</a:t>
-            </a:r>
-            <a:endParaRPr sz="1050" b="1">
+              <a:t> / IPC</a:t>
+            </a:r>
+            <a:r>
+              <a:rPr lang="zh-CN" sz="1050" b="1">
+                <a:solidFill>
+                  <a:srgbClr val="2563EB"/>
+                </a:solidFill>
+                <a:latin typeface="HarmonyOS Sans SC" panose="00000500000000000000" charset="-122"/>
+                <a:ea typeface="HarmonyOS Sans SC" panose="00000500000000000000" charset="-122"/>
+                <a:cs typeface="HarmonyOS Sans SC" panose="00000500000000000000" charset="-122"/>
+              </a:rPr>
+              <a:t>远程</a:t>
+            </a:r>
+            <a:r>
+              <a:rPr lang="zh-CN" sz="1050" b="1">
+                <a:solidFill>
+                  <a:srgbClr val="2563EB"/>
+                </a:solidFill>
+                <a:latin typeface="HarmonyOS Sans SC" panose="00000500000000000000" charset="-122"/>
+                <a:ea typeface="HarmonyOS Sans SC" panose="00000500000000000000" charset="-122"/>
+                <a:cs typeface="HarmonyOS Sans SC" panose="00000500000000000000" charset="-122"/>
+              </a:rPr>
+              <a:t>控制</a:t>
+            </a:r>
+            <a:endParaRPr lang="zh-CN" sz="1050" b="1">
               <a:solidFill>
                 <a:srgbClr val="2563EB"/>
               </a:solidFill>
@@ -5242,12 +5161,12 @@
         </p:nvSpPr>
         <p:spPr>
           <a:xfrm rot="5400000">
-            <a:off x="3035935" y="6448425"/>
+            <a:off x="3065145" y="6448425"/>
             <a:ext cx="1714500" cy="323850"/>
           </a:xfrm>
           <a:prstGeom prst="roundRect">
             <a:avLst>
-              <a:gd name="adj" fmla="val 23529"/>
+              <a:gd name="adj" fmla="val 0"/>
             </a:avLst>
           </a:prstGeom>
           <a:noFill/>
@@ -5266,7 +5185,7 @@
           </a:extLst>
         </p:spPr>
         <p:txBody>
-          <a:bodyPr/>
+          <a:bodyPr anchor="ctr" anchorCtr="0"/>
           <a:lstStyle/>
           <a:p>
             <a:pPr algn="l">
@@ -5285,9 +5204,42 @@
                 <a:ea typeface="HarmonyOS Sans SC" panose="00000500000000000000" charset="-122"/>
                 <a:cs typeface="HarmonyOS Sans SC" panose="00000500000000000000" charset="-122"/>
               </a:rPr>
-              <a:t>任务下发 / 结果回传</a:t>
-            </a:r>
-            <a:endParaRPr sz="1050" b="1">
+              <a:t>任务下发</a:t>
+            </a:r>
+            <a:r>
+              <a:rPr lang="zh-CN" sz="1050" b="1">
+                <a:solidFill>
+                  <a:srgbClr val="7030A0"/>
+                </a:solidFill>
+                <a:latin typeface="HarmonyOS Sans SC" panose="00000500000000000000" charset="-122"/>
+                <a:ea typeface="HarmonyOS Sans SC" panose="00000500000000000000" charset="-122"/>
+                <a:cs typeface="HarmonyOS Sans SC" panose="00000500000000000000" charset="-122"/>
+              </a:rPr>
+              <a:t>到本地</a:t>
+            </a:r>
+            <a:r>
+              <a:rPr lang="en-US" altLang="zh-CN" sz="1050" b="1">
+                <a:solidFill>
+                  <a:srgbClr val="7030A0"/>
+                </a:solidFill>
+                <a:latin typeface="HarmonyOS Sans SC" panose="00000500000000000000" charset="-122"/>
+                <a:ea typeface="HarmonyOS Sans SC" panose="00000500000000000000" charset="-122"/>
+                <a:cs typeface="HarmonyOS Sans SC" panose="00000500000000000000" charset="-122"/>
+              </a:rPr>
+              <a:t> w</a:t>
+            </a:r>
+            <a:r>
+              <a:rPr lang="en-US" altLang="zh-CN" sz="1050" b="1">
+                <a:solidFill>
+                  <a:srgbClr val="7030A0"/>
+                </a:solidFill>
+                <a:latin typeface="HarmonyOS Sans SC" panose="00000500000000000000" charset="-122"/>
+                <a:ea typeface="HarmonyOS Sans SC" panose="00000500000000000000" charset="-122"/>
+                <a:cs typeface="HarmonyOS Sans SC" panose="00000500000000000000" charset="-122"/>
+              </a:rPr>
+              <a:t>orker</a:t>
+            </a:r>
+            <a:endParaRPr lang="en-US" altLang="zh-CN" sz="1050" b="1">
               <a:solidFill>
                 <a:srgbClr val="7030A0"/>
               </a:solidFill>
@@ -5301,16 +5253,13 @@
       <p:cxnSp>
         <p:nvCxnSpPr>
           <p:cNvPr id="140" name="直接箭头连接符 139"/>
-          <p:cNvCxnSpPr>
-            <a:stCxn id="19" idx="0"/>
-            <a:endCxn id="18" idx="2"/>
-          </p:cNvCxnSpPr>
+          <p:cNvCxnSpPr/>
           <p:nvPr/>
         </p:nvCxnSpPr>
         <p:spPr>
           <a:xfrm flipV="1">
-            <a:off x="5953125" y="3829050"/>
-            <a:ext cx="0" cy="323850"/>
+            <a:off x="5748020" y="2838450"/>
+            <a:ext cx="0" cy="266700"/>
           </a:xfrm>
           <a:prstGeom prst="straightConnector1">
             <a:avLst/>
@@ -5335,12 +5284,12 @@
         </p:nvSpPr>
         <p:spPr>
           <a:xfrm>
-            <a:off x="5891530" y="2828925"/>
+            <a:off x="4427855" y="2828925"/>
             <a:ext cx="1310640" cy="323850"/>
           </a:xfrm>
           <a:prstGeom prst="roundRect">
             <a:avLst>
-              <a:gd name="adj" fmla="val 23529"/>
+              <a:gd name="adj" fmla="val 0"/>
             </a:avLst>
           </a:prstGeom>
           <a:noFill/>
@@ -5359,10 +5308,10 @@
           </a:extLst>
         </p:spPr>
         <p:txBody>
-          <a:bodyPr/>
+          <a:bodyPr anchor="ctr" anchorCtr="0"/>
           <a:lstStyle/>
           <a:p>
-            <a:pPr algn="ctr">
+            <a:pPr algn="r">
               <a:defRPr sz="1050" b="1">
                 <a:solidFill>
                   <a:srgbClr val="C2410C"/>
@@ -5397,15 +5346,15 @@
         </p:nvCxnSpPr>
         <p:spPr>
           <a:xfrm flipV="1">
-            <a:off x="5219700" y="901065"/>
-            <a:ext cx="0" cy="1213485"/>
+            <a:off x="5459730" y="1221740"/>
+            <a:ext cx="0" cy="892810"/>
           </a:xfrm>
           <a:prstGeom prst="straightConnector1">
             <a:avLst/>
           </a:prstGeom>
           <a:ln w="23813">
             <a:solidFill>
-              <a:srgbClr val="B45309"/>
+              <a:srgbClr val="7030A0"/>
             </a:solidFill>
             <a:prstDash val="solid"/>
             <a:headEnd type="none" w="med" len="med"/>
@@ -5423,29 +5372,34 @@
         </p:nvSpPr>
         <p:spPr>
           <a:xfrm>
-            <a:off x="5486400" y="1045845"/>
+            <a:off x="5459730" y="1214120"/>
             <a:ext cx="933450" cy="323850"/>
           </a:xfrm>
           <a:prstGeom prst="roundRect">
             <a:avLst>
-              <a:gd name="adj" fmla="val 23529"/>
+              <a:gd name="adj" fmla="val 0"/>
             </a:avLst>
           </a:prstGeom>
-          <a:solidFill>
-            <a:srgbClr val="FFFFFF"/>
-          </a:solidFill>
+          <a:noFill/>
           <a:ln w="7620">
-            <a:solidFill>
-              <a:srgbClr val="D7DEE8"/>
-            </a:solidFill>
+            <a:noFill/>
             <a:prstDash val="solid"/>
           </a:ln>
+          <a:extLst>
+            <a:ext uri="{909E8E84-426E-40DD-AFC4-6F175D3DCCD1}">
+              <a14:hiddenFill xmlns:a14="http://schemas.microsoft.com/office/drawing/2010/main">
+                <a:solidFill>
+                  <a:srgbClr val="FFFFFF"/>
+                </a:solidFill>
+              </a14:hiddenFill>
+            </a:ext>
+          </a:extLst>
         </p:spPr>
         <p:txBody>
-          <a:bodyPr/>
+          <a:bodyPr anchor="ctr" anchorCtr="0"/>
           <a:lstStyle/>
           <a:p>
-            <a:pPr algn="ctr">
+            <a:pPr algn="l">
               <a:defRPr sz="1050" b="1">
                 <a:solidFill>
                   <a:srgbClr val="B45309"/>
@@ -5482,12 +5436,12 @@
         </p:nvSpPr>
         <p:spPr>
           <a:xfrm rot="5400000">
-            <a:off x="7272655" y="4173220"/>
-            <a:ext cx="1540510" cy="323850"/>
+            <a:off x="6911975" y="3810000"/>
+            <a:ext cx="2268220" cy="323850"/>
           </a:xfrm>
           <a:prstGeom prst="roundRect">
             <a:avLst>
-              <a:gd name="adj" fmla="val 23529"/>
+              <a:gd name="adj" fmla="val 0"/>
             </a:avLst>
           </a:prstGeom>
           <a:noFill/>
@@ -5497,7 +5451,7 @@
           </a:ln>
         </p:spPr>
         <p:txBody>
-          <a:bodyPr>
+          <a:bodyPr anchor="ctr" anchorCtr="0">
             <a:noAutofit/>
           </a:bodyPr>
           <a:lstStyle/>
@@ -5512,6 +5466,30 @@
                 </a:solidFill>
               </a:defRPr>
             </a:pPr>
+            <a:r>
+              <a:rPr lang="zh-CN">
+                <a:solidFill>
+                  <a:srgbClr val="7030A0"/>
+                </a:solidFill>
+                <a:latin typeface="HarmonyOS Sans SC" panose="00000500000000000000" charset="-122"/>
+                <a:ea typeface="HarmonyOS Sans SC" panose="00000500000000000000" charset="-122"/>
+                <a:cs typeface="HarmonyOS Sans SC" panose="00000500000000000000" charset="-122"/>
+                <a:sym typeface="+mn-ea"/>
+              </a:rPr>
+              <a:t>文件上传</a:t>
+            </a:r>
+            <a:r>
+              <a:rPr lang="en-US" altLang="zh-CN">
+                <a:solidFill>
+                  <a:srgbClr val="7030A0"/>
+                </a:solidFill>
+                <a:latin typeface="HarmonyOS Sans SC" panose="00000500000000000000" charset="-122"/>
+                <a:ea typeface="HarmonyOS Sans SC" panose="00000500000000000000" charset="-122"/>
+                <a:cs typeface="HarmonyOS Sans SC" panose="00000500000000000000" charset="-122"/>
+                <a:sym typeface="+mn-ea"/>
+              </a:rPr>
+              <a:t> / </a:t>
+            </a:r>
             <a:r>
               <a:rPr lang="zh-CN">
                 <a:solidFill>
@@ -5570,12 +5548,12 @@
         </p:nvSpPr>
         <p:spPr>
           <a:xfrm rot="5400000">
-            <a:off x="7290435" y="6343650"/>
+            <a:off x="7293610" y="6343650"/>
             <a:ext cx="1504950" cy="323850"/>
           </a:xfrm>
           <a:prstGeom prst="roundRect">
             <a:avLst>
-              <a:gd name="adj" fmla="val 23529"/>
+              <a:gd name="adj" fmla="val 0"/>
             </a:avLst>
           </a:prstGeom>
           <a:noFill/>
@@ -5585,7 +5563,7 @@
           </a:ln>
         </p:spPr>
         <p:txBody>
-          <a:bodyPr/>
+          <a:bodyPr anchor="ctr" anchorCtr="0"/>
           <a:lstStyle/>
           <a:p>
             <a:pPr algn="l">
@@ -6463,7 +6441,7 @@
         <p:spPr>
           <a:xfrm>
             <a:off x="3409950" y="3076575"/>
-            <a:ext cx="490855" cy="0"/>
+            <a:ext cx="518160" cy="0"/>
           </a:xfrm>
           <a:prstGeom prst="line">
             <a:avLst/>
@@ -6497,7 +6475,7 @@
         </p:nvCxnSpPr>
         <p:spPr>
           <a:xfrm>
-            <a:off x="3900805" y="3072765"/>
+            <a:off x="3922395" y="3072765"/>
             <a:ext cx="0" cy="2020570"/>
           </a:xfrm>
           <a:prstGeom prst="line">
@@ -6532,8 +6510,8 @@
         </p:nvCxnSpPr>
         <p:spPr>
           <a:xfrm>
-            <a:off x="3898900" y="5090160"/>
-            <a:ext cx="535305" cy="0"/>
+            <a:off x="3917315" y="5090160"/>
+            <a:ext cx="516890" cy="0"/>
           </a:xfrm>
           <a:prstGeom prst="straightConnector1">
             <a:avLst/>
@@ -6601,8 +6579,8 @@
         </p:nvCxnSpPr>
         <p:spPr>
           <a:xfrm flipV="1">
-            <a:off x="5950585" y="2838450"/>
-            <a:ext cx="0" cy="266065"/>
+            <a:off x="5738495" y="3829050"/>
+            <a:ext cx="0" cy="325755"/>
           </a:xfrm>
           <a:prstGeom prst="straightConnector1">
             <a:avLst/>
@@ -6627,7 +6605,7 @@
         </p:nvSpPr>
         <p:spPr>
           <a:xfrm>
-            <a:off x="971550" y="6144260"/>
+            <a:off x="2126615" y="6060440"/>
             <a:ext cx="1035685" cy="304800"/>
           </a:xfrm>
           <a:prstGeom prst="roundRect">
@@ -6682,7 +6660,7 @@
         </p:nvCxnSpPr>
         <p:spPr>
           <a:xfrm>
-            <a:off x="2644140" y="5276215"/>
+            <a:off x="1512570" y="5192395"/>
             <a:ext cx="0" cy="870585"/>
           </a:xfrm>
           <a:prstGeom prst="straightConnector1">
@@ -6718,7 +6696,7 @@
         </p:nvCxnSpPr>
         <p:spPr>
           <a:xfrm>
-            <a:off x="1489710" y="5276215"/>
+            <a:off x="2644775" y="5192395"/>
             <a:ext cx="0" cy="163195"/>
           </a:xfrm>
           <a:prstGeom prst="straightConnector1">
@@ -6754,7 +6732,7 @@
         </p:nvCxnSpPr>
         <p:spPr>
           <a:xfrm>
-            <a:off x="1489710" y="5977255"/>
+            <a:off x="2644775" y="5893435"/>
             <a:ext cx="0" cy="163195"/>
           </a:xfrm>
           <a:prstGeom prst="straightConnector1">
@@ -6790,7 +6768,7 @@
         </p:nvCxnSpPr>
         <p:spPr>
           <a:xfrm>
-            <a:off x="3412490" y="5596255"/>
+            <a:off x="3412490" y="5654675"/>
             <a:ext cx="1021715" cy="0"/>
           </a:xfrm>
           <a:prstGeom prst="straightConnector1">
@@ -6833,7 +6811,7 @@
           </a:xfrm>
           <a:prstGeom prst="roundRect">
             <a:avLst>
-              <a:gd name="adj" fmla="val 8451"/>
+              <a:gd name="adj" fmla="val 20124"/>
             </a:avLst>
           </a:prstGeom>
           <a:solidFill>
@@ -7033,6 +7011,1630 @@
           </a:fontRef>
         </p:style>
       </p:cxnSp>
+      <p:sp>
+        <p:nvSpPr>
+          <p:cNvPr id="2" name="daemon"/>
+          <p:cNvSpPr>
+            <a:spLocks noGrp="1"/>
+          </p:cNvSpPr>
+          <p:nvPr/>
+        </p:nvSpPr>
+        <p:spPr>
+          <a:xfrm>
+            <a:off x="6043930" y="2588895"/>
+            <a:ext cx="1487805" cy="1240155"/>
+          </a:xfrm>
+          <a:prstGeom prst="roundRect">
+            <a:avLst>
+              <a:gd name="adj" fmla="val 7682"/>
+            </a:avLst>
+          </a:prstGeom>
+          <a:solidFill>
+            <a:srgbClr val="EEF2FF"/>
+          </a:solidFill>
+          <a:ln w="14288">
+            <a:solidFill>
+              <a:srgbClr val="B9B7F4"/>
+            </a:solidFill>
+            <a:prstDash val="solid"/>
+          </a:ln>
+        </p:spPr>
+        <p:style>
+          <a:lnRef idx="0">
+            <a:srgbClr val="FFFFFF"/>
+          </a:lnRef>
+          <a:fillRef idx="0">
+            <a:srgbClr val="FFFFFF"/>
+          </a:fillRef>
+          <a:effectRef idx="4">
+            <a:srgbClr val="FFFFFF"/>
+          </a:effectRef>
+          <a:fontRef idx="major"/>
+        </p:style>
+        <p:txBody>
+          <a:bodyPr/>
+          <a:lstStyle/>
+          <a:p>
+            <a:pPr algn="ctr">
+              <a:defRPr sz="1800" b="1">
+                <a:solidFill>
+                  <a:srgbClr val="4F46E5"/>
+                </a:solidFill>
+              </a:defRPr>
+            </a:pPr>
+            <a:r>
+              <a:rPr lang="zh-CN" altLang="en-US" sz="1400" b="1">
+                <a:solidFill>
+                  <a:srgbClr val="4F46E5"/>
+                </a:solidFill>
+                <a:latin typeface="HarmonyOS Sans SC" panose="00000500000000000000" charset="-122"/>
+                <a:ea typeface="HarmonyOS Sans SC" panose="00000500000000000000" charset="-122"/>
+                <a:cs typeface="HarmonyOS Sans SC" panose="00000500000000000000" charset="-122"/>
+              </a:rPr>
+              <a:t>无头前端</a:t>
+            </a:r>
+            <a:endParaRPr lang="en-US" sz="1400" b="1">
+              <a:solidFill>
+                <a:srgbClr val="4F46E5"/>
+              </a:solidFill>
+              <a:latin typeface="HarmonyOS Sans SC" panose="00000500000000000000" charset="-122"/>
+              <a:ea typeface="HarmonyOS Sans SC" panose="00000500000000000000" charset="-122"/>
+              <a:cs typeface="HarmonyOS Sans SC" panose="00000500000000000000" charset="-122"/>
+            </a:endParaRPr>
+          </a:p>
+          <a:p>
+            <a:pPr algn="ctr">
+              <a:defRPr sz="1800" b="1">
+                <a:solidFill>
+                  <a:srgbClr val="4F46E5"/>
+                </a:solidFill>
+              </a:defRPr>
+            </a:pPr>
+            <a:r>
+              <a:rPr lang="en-US" sz="1400" b="1">
+                <a:solidFill>
+                  <a:srgbClr val="4F46E5"/>
+                </a:solidFill>
+                <a:latin typeface="HarmonyOS Sans SC" panose="00000500000000000000" charset="-122"/>
+                <a:ea typeface="HarmonyOS Sans SC" panose="00000500000000000000" charset="-122"/>
+                <a:cs typeface="HarmonyOS Sans SC" panose="00000500000000000000" charset="-122"/>
+              </a:rPr>
+              <a:t>AutoFluid CLI</a:t>
+            </a:r>
+            <a:endParaRPr lang="en-US" sz="1400" b="1">
+              <a:solidFill>
+                <a:srgbClr val="4F46E5"/>
+              </a:solidFill>
+              <a:latin typeface="HarmonyOS Sans SC" panose="00000500000000000000" charset="-122"/>
+              <a:ea typeface="HarmonyOS Sans SC" panose="00000500000000000000" charset="-122"/>
+              <a:cs typeface="HarmonyOS Sans SC" panose="00000500000000000000" charset="-122"/>
+            </a:endParaRPr>
+          </a:p>
+        </p:txBody>
+      </p:sp>
+      <p:sp>
+        <p:nvSpPr>
+          <p:cNvPr id="3" name="frontend-body"/>
+          <p:cNvSpPr>
+            <a:spLocks noGrp="1"/>
+          </p:cNvSpPr>
+          <p:nvPr/>
+        </p:nvSpPr>
+        <p:spPr>
+          <a:xfrm>
+            <a:off x="5685790" y="2952750"/>
+            <a:ext cx="2228850" cy="800100"/>
+          </a:xfrm>
+          <a:prstGeom prst="rect">
+            <a:avLst/>
+          </a:prstGeom>
+          <a:noFill/>
+          <a:ln w="0">
+            <a:noFill/>
+            <a:prstDash val="solid"/>
+          </a:ln>
+        </p:spPr>
+        <p:txBody>
+          <a:bodyPr anchor="ctr" anchorCtr="0"/>
+          <a:lstStyle/>
+          <a:p>
+            <a:pPr algn="ctr">
+              <a:defRPr sz="1275" b="0">
+                <a:solidFill>
+                  <a:srgbClr val="172033"/>
+                </a:solidFill>
+              </a:defRPr>
+            </a:pPr>
+            <a:r>
+              <a:rPr sz="1200" b="0">
+                <a:solidFill>
+                  <a:srgbClr val="172033"/>
+                </a:solidFill>
+                <a:latin typeface="HarmonyOS Sans SC" panose="00000500000000000000" charset="-122"/>
+                <a:ea typeface="HarmonyOS Sans SC" panose="00000500000000000000" charset="-122"/>
+                <a:cs typeface="HarmonyOS Sans SC" panose="00000500000000000000" charset="-122"/>
+              </a:rPr>
+              <a:t>启动 / 暂停 / 检查</a:t>
+            </a:r>
+            <a:endParaRPr sz="1200" b="0">
+              <a:solidFill>
+                <a:srgbClr val="172033"/>
+              </a:solidFill>
+              <a:latin typeface="HarmonyOS Sans SC" panose="00000500000000000000" charset="-122"/>
+              <a:ea typeface="HarmonyOS Sans SC" panose="00000500000000000000" charset="-122"/>
+              <a:cs typeface="HarmonyOS Sans SC" panose="00000500000000000000" charset="-122"/>
+            </a:endParaRPr>
+          </a:p>
+          <a:p>
+            <a:pPr algn="ctr">
+              <a:defRPr sz="1275" b="0">
+                <a:solidFill>
+                  <a:srgbClr val="172033"/>
+                </a:solidFill>
+              </a:defRPr>
+            </a:pPr>
+            <a:r>
+              <a:rPr sz="1200" b="0">
+                <a:solidFill>
+                  <a:srgbClr val="172033"/>
+                </a:solidFill>
+                <a:latin typeface="HarmonyOS Sans SC" panose="00000500000000000000" charset="-122"/>
+                <a:ea typeface="HarmonyOS Sans SC" panose="00000500000000000000" charset="-122"/>
+                <a:cs typeface="HarmonyOS Sans SC" panose="00000500000000000000" charset="-122"/>
+              </a:rPr>
+              <a:t>状态查看 / IPC 访问</a:t>
+            </a:r>
+            <a:endParaRPr sz="1200" b="0">
+              <a:solidFill>
+                <a:srgbClr val="172033"/>
+              </a:solidFill>
+              <a:latin typeface="HarmonyOS Sans SC" panose="00000500000000000000" charset="-122"/>
+              <a:ea typeface="HarmonyOS Sans SC" panose="00000500000000000000" charset="-122"/>
+              <a:cs typeface="HarmonyOS Sans SC" panose="00000500000000000000" charset="-122"/>
+            </a:endParaRPr>
+          </a:p>
+        </p:txBody>
+      </p:sp>
+      <p:cxnSp>
+        <p:nvCxnSpPr>
+          <p:cNvPr id="69" name="直接连接符 68"/>
+          <p:cNvCxnSpPr/>
+          <p:nvPr/>
+        </p:nvCxnSpPr>
+        <p:spPr>
+          <a:xfrm>
+            <a:off x="5927725" y="2266950"/>
+            <a:ext cx="1229360" cy="0"/>
+          </a:xfrm>
+          <a:prstGeom prst="line">
+            <a:avLst/>
+          </a:prstGeom>
+          <a:ln>
+            <a:solidFill>
+              <a:srgbClr val="C2410C"/>
+            </a:solidFill>
+          </a:ln>
+        </p:spPr>
+        <p:style>
+          <a:lnRef idx="2">
+            <a:schemeClr val="accent1"/>
+          </a:lnRef>
+          <a:fillRef idx="0">
+            <a:srgbClr val="FFFFFF"/>
+          </a:fillRef>
+          <a:effectRef idx="0">
+            <a:srgbClr val="FFFFFF"/>
+          </a:effectRef>
+          <a:fontRef idx="minor">
+            <a:schemeClr val="tx1"/>
+          </a:fontRef>
+        </p:style>
+      </p:cxnSp>
+      <p:cxnSp>
+        <p:nvCxnSpPr>
+          <p:cNvPr id="75" name="直接箭头连接符 74"/>
+          <p:cNvCxnSpPr/>
+          <p:nvPr/>
+        </p:nvCxnSpPr>
+        <p:spPr>
+          <a:xfrm>
+            <a:off x="7151370" y="2265045"/>
+            <a:ext cx="0" cy="334010"/>
+          </a:xfrm>
+          <a:prstGeom prst="straightConnector1">
+            <a:avLst/>
+          </a:prstGeom>
+          <a:ln>
+            <a:solidFill>
+              <a:srgbClr val="C2410C"/>
+            </a:solidFill>
+            <a:tailEnd type="arrow"/>
+          </a:ln>
+        </p:spPr>
+        <p:style>
+          <a:lnRef idx="2">
+            <a:schemeClr val="accent1"/>
+          </a:lnRef>
+          <a:fillRef idx="0">
+            <a:srgbClr val="FFFFFF"/>
+          </a:fillRef>
+          <a:effectRef idx="0">
+            <a:srgbClr val="FFFFFF"/>
+          </a:effectRef>
+          <a:fontRef idx="minor">
+            <a:schemeClr val="tx1"/>
+          </a:fontRef>
+        </p:style>
+      </p:cxnSp>
+      <p:cxnSp>
+        <p:nvCxnSpPr>
+          <p:cNvPr id="98" name="直接连接符 97"/>
+          <p:cNvCxnSpPr/>
+          <p:nvPr/>
+        </p:nvCxnSpPr>
+        <p:spPr>
+          <a:xfrm flipV="1">
+            <a:off x="7060565" y="2355850"/>
+            <a:ext cx="0" cy="232410"/>
+          </a:xfrm>
+          <a:prstGeom prst="line">
+            <a:avLst/>
+          </a:prstGeom>
+          <a:ln>
+            <a:solidFill>
+              <a:srgbClr val="C2410C"/>
+            </a:solidFill>
+          </a:ln>
+        </p:spPr>
+        <p:style>
+          <a:lnRef idx="2">
+            <a:schemeClr val="accent1"/>
+          </a:lnRef>
+          <a:fillRef idx="0">
+            <a:srgbClr val="FFFFFF"/>
+          </a:fillRef>
+          <a:effectRef idx="0">
+            <a:srgbClr val="FFFFFF"/>
+          </a:effectRef>
+          <a:fontRef idx="minor">
+            <a:schemeClr val="tx1"/>
+          </a:fontRef>
+        </p:style>
+      </p:cxnSp>
+      <p:cxnSp>
+        <p:nvCxnSpPr>
+          <p:cNvPr id="104" name="直接箭头连接符 103"/>
+          <p:cNvCxnSpPr/>
+          <p:nvPr/>
+        </p:nvCxnSpPr>
+        <p:spPr>
+          <a:xfrm flipH="1">
+            <a:off x="5935980" y="2362835"/>
+            <a:ext cx="1128395" cy="0"/>
+          </a:xfrm>
+          <a:prstGeom prst="straightConnector1">
+            <a:avLst/>
+          </a:prstGeom>
+          <a:ln>
+            <a:solidFill>
+              <a:srgbClr val="C2410C"/>
+            </a:solidFill>
+            <a:tailEnd type="arrow"/>
+          </a:ln>
+        </p:spPr>
+        <p:style>
+          <a:lnRef idx="2">
+            <a:schemeClr val="accent1"/>
+          </a:lnRef>
+          <a:fillRef idx="0">
+            <a:srgbClr val="FFFFFF"/>
+          </a:fillRef>
+          <a:effectRef idx="0">
+            <a:srgbClr val="FFFFFF"/>
+          </a:effectRef>
+          <a:fontRef idx="minor">
+            <a:schemeClr val="tx1"/>
+          </a:fontRef>
+        </p:style>
+      </p:cxnSp>
+      <p:cxnSp>
+        <p:nvCxnSpPr>
+          <p:cNvPr id="106" name="直接箭头连接符 105"/>
+          <p:cNvCxnSpPr/>
+          <p:nvPr/>
+        </p:nvCxnSpPr>
+        <p:spPr>
+          <a:xfrm flipV="1">
+            <a:off x="7060565" y="3827145"/>
+            <a:ext cx="0" cy="325755"/>
+          </a:xfrm>
+          <a:prstGeom prst="straightConnector1">
+            <a:avLst/>
+          </a:prstGeom>
+          <a:ln w="23813">
+            <a:solidFill>
+              <a:srgbClr val="C2410C"/>
+            </a:solidFill>
+            <a:prstDash val="solid"/>
+            <a:headEnd type="none" w="med" len="med"/>
+            <a:tailEnd type="arrow" w="med" len="med"/>
+          </a:ln>
+        </p:spPr>
+      </p:cxnSp>
+      <p:cxnSp>
+        <p:nvCxnSpPr>
+          <p:cNvPr id="107" name="直接箭头连接符 106"/>
+          <p:cNvCxnSpPr/>
+          <p:nvPr/>
+        </p:nvCxnSpPr>
+        <p:spPr>
+          <a:xfrm>
+            <a:off x="7151370" y="3829050"/>
+            <a:ext cx="0" cy="318135"/>
+          </a:xfrm>
+          <a:prstGeom prst="straightConnector1">
+            <a:avLst/>
+          </a:prstGeom>
+          <a:ln w="23813">
+            <a:solidFill>
+              <a:srgbClr val="C2410C"/>
+            </a:solidFill>
+            <a:prstDash val="solid"/>
+            <a:headEnd type="none" w="med" len="med"/>
+            <a:tailEnd type="arrow" w="med" len="med"/>
+          </a:ln>
+        </p:spPr>
+      </p:cxnSp>
+      <p:sp>
+        <p:nvSpPr>
+          <p:cNvPr id="108" name="label-Webhook POST"/>
+          <p:cNvSpPr>
+            <a:spLocks noGrp="1"/>
+          </p:cNvSpPr>
+          <p:nvPr/>
+        </p:nvSpPr>
+        <p:spPr>
+          <a:xfrm>
+            <a:off x="5753735" y="3830955"/>
+            <a:ext cx="1310640" cy="323850"/>
+          </a:xfrm>
+          <a:prstGeom prst="roundRect">
+            <a:avLst>
+              <a:gd name="adj" fmla="val 0"/>
+            </a:avLst>
+          </a:prstGeom>
+          <a:noFill/>
+          <a:ln w="7620">
+            <a:noFill/>
+            <a:prstDash val="solid"/>
+          </a:ln>
+          <a:extLst>
+            <a:ext uri="{909E8E84-426E-40DD-AFC4-6F175D3DCCD1}">
+              <a14:hiddenFill xmlns:a14="http://schemas.microsoft.com/office/drawing/2010/main">
+                <a:solidFill>
+                  <a:srgbClr val="FFFFFF"/>
+                </a:solidFill>
+              </a14:hiddenFill>
+            </a:ext>
+          </a:extLst>
+        </p:spPr>
+        <p:txBody>
+          <a:bodyPr anchor="ctr" anchorCtr="0"/>
+          <a:lstStyle/>
+          <a:p>
+            <a:pPr algn="r">
+              <a:defRPr sz="1050" b="1">
+                <a:solidFill>
+                  <a:srgbClr val="C2410C"/>
+                </a:solidFill>
+              </a:defRPr>
+            </a:pPr>
+            <a:r>
+              <a:rPr lang="zh-CN" altLang="en-US" sz="1050" b="1">
+                <a:solidFill>
+                  <a:srgbClr val="C2410C"/>
+                </a:solidFill>
+                <a:latin typeface="HarmonyOS Sans SC" panose="00000500000000000000" charset="-122"/>
+                <a:ea typeface="HarmonyOS Sans SC" panose="00000500000000000000" charset="-122"/>
+              </a:rPr>
+              <a:t>本地</a:t>
+            </a:r>
+            <a:r>
+              <a:rPr lang="en-US" altLang="zh-CN" sz="1050" b="1">
+                <a:solidFill>
+                  <a:srgbClr val="C2410C"/>
+                </a:solidFill>
+                <a:latin typeface="HarmonyOS Sans SC" panose="00000500000000000000" charset="-122"/>
+                <a:ea typeface="HarmonyOS Sans SC" panose="00000500000000000000" charset="-122"/>
+              </a:rPr>
+              <a:t> IPC </a:t>
+            </a:r>
+            <a:r>
+              <a:rPr lang="zh-CN" altLang="en-US" sz="1050" b="1">
+                <a:solidFill>
+                  <a:srgbClr val="C2410C"/>
+                </a:solidFill>
+                <a:latin typeface="HarmonyOS Sans SC" panose="00000500000000000000" charset="-122"/>
+                <a:ea typeface="HarmonyOS Sans SC" panose="00000500000000000000" charset="-122"/>
+              </a:rPr>
+              <a:t>控制</a:t>
+            </a:r>
+            <a:endParaRPr lang="zh-CN" altLang="en-US" sz="1050" b="1">
+              <a:solidFill>
+                <a:srgbClr val="C2410C"/>
+              </a:solidFill>
+              <a:latin typeface="HarmonyOS Sans SC" panose="00000500000000000000" charset="-122"/>
+              <a:ea typeface="HarmonyOS Sans SC" panose="00000500000000000000" charset="-122"/>
+            </a:endParaRPr>
+          </a:p>
+        </p:txBody>
+      </p:sp>
+      <p:sp>
+        <p:nvSpPr>
+          <p:cNvPr id="109" name="label-Webhook POST"/>
+          <p:cNvSpPr>
+            <a:spLocks noGrp="1"/>
+          </p:cNvSpPr>
+          <p:nvPr/>
+        </p:nvSpPr>
+        <p:spPr>
+          <a:xfrm>
+            <a:off x="5749925" y="2313940"/>
+            <a:ext cx="1310640" cy="324485"/>
+          </a:xfrm>
+          <a:prstGeom prst="roundRect">
+            <a:avLst>
+              <a:gd name="adj" fmla="val 0"/>
+            </a:avLst>
+          </a:prstGeom>
+          <a:noFill/>
+          <a:ln w="7620">
+            <a:noFill/>
+            <a:prstDash val="solid"/>
+          </a:ln>
+          <a:extLst>
+            <a:ext uri="{909E8E84-426E-40DD-AFC4-6F175D3DCCD1}">
+              <a14:hiddenFill xmlns:a14="http://schemas.microsoft.com/office/drawing/2010/main">
+                <a:solidFill>
+                  <a:srgbClr val="FFFFFF"/>
+                </a:solidFill>
+              </a14:hiddenFill>
+            </a:ext>
+          </a:extLst>
+        </p:spPr>
+        <p:txBody>
+          <a:bodyPr anchor="ctr" anchorCtr="0"/>
+          <a:lstStyle/>
+          <a:p>
+            <a:pPr algn="r">
+              <a:defRPr sz="1050" b="1">
+                <a:solidFill>
+                  <a:srgbClr val="C2410C"/>
+                </a:solidFill>
+              </a:defRPr>
+            </a:pPr>
+            <a:r>
+              <a:rPr lang="en-US" sz="1050" b="1">
+                <a:solidFill>
+                  <a:srgbClr val="C2410C"/>
+                </a:solidFill>
+                <a:latin typeface="HarmonyOS Sans SC" panose="00000500000000000000" charset="-122"/>
+                <a:ea typeface="HarmonyOS Sans SC" panose="00000500000000000000" charset="-122"/>
+              </a:rPr>
+              <a:t>AI </a:t>
+            </a:r>
+            <a:r>
+              <a:rPr lang="zh-CN" altLang="en-US" sz="1050" b="1">
+                <a:solidFill>
+                  <a:srgbClr val="C2410C"/>
+                </a:solidFill>
+                <a:latin typeface="HarmonyOS Sans SC" panose="00000500000000000000" charset="-122"/>
+                <a:ea typeface="HarmonyOS Sans SC" panose="00000500000000000000" charset="-122"/>
+              </a:rPr>
+              <a:t>调用</a:t>
+            </a:r>
+            <a:r>
+              <a:rPr lang="zh-CN" altLang="en-US" sz="1050" b="1">
+                <a:solidFill>
+                  <a:srgbClr val="C2410C"/>
+                </a:solidFill>
+                <a:latin typeface="HarmonyOS Sans SC" panose="00000500000000000000" charset="-122"/>
+                <a:ea typeface="HarmonyOS Sans SC" panose="00000500000000000000" charset="-122"/>
+              </a:rPr>
+              <a:t>交互</a:t>
+            </a:r>
+            <a:endParaRPr lang="zh-CN" altLang="en-US" sz="1050" b="1">
+              <a:solidFill>
+                <a:srgbClr val="C2410C"/>
+              </a:solidFill>
+              <a:latin typeface="HarmonyOS Sans SC" panose="00000500000000000000" charset="-122"/>
+              <a:ea typeface="HarmonyOS Sans SC" panose="00000500000000000000" charset="-122"/>
+            </a:endParaRPr>
+          </a:p>
+        </p:txBody>
+      </p:sp>
+      <p:sp>
+        <p:nvSpPr>
+          <p:cNvPr id="110" name="label-任务下发 / 结果回传"/>
+          <p:cNvSpPr>
+            <a:spLocks noGrp="1"/>
+          </p:cNvSpPr>
+          <p:nvPr/>
+        </p:nvSpPr>
+        <p:spPr>
+          <a:xfrm rot="5400000">
+            <a:off x="3496628" y="4996180"/>
+            <a:ext cx="851535" cy="467360"/>
+          </a:xfrm>
+          <a:prstGeom prst="roundRect">
+            <a:avLst>
+              <a:gd name="adj" fmla="val 0"/>
+            </a:avLst>
+          </a:prstGeom>
+          <a:noFill/>
+          <a:ln w="7620">
+            <a:noFill/>
+            <a:prstDash val="solid"/>
+          </a:ln>
+          <a:extLst>
+            <a:ext uri="{909E8E84-426E-40DD-AFC4-6F175D3DCCD1}">
+              <a14:hiddenFill xmlns:a14="http://schemas.microsoft.com/office/drawing/2010/main">
+                <a:solidFill>
+                  <a:srgbClr val="FFFFFF"/>
+                </a:solidFill>
+              </a14:hiddenFill>
+            </a:ext>
+          </a:extLst>
+        </p:spPr>
+        <p:txBody>
+          <a:bodyPr anchor="ctr" anchorCtr="0"/>
+          <a:lstStyle/>
+          <a:p>
+            <a:pPr algn="r">
+              <a:defRPr sz="1050" b="1">
+                <a:solidFill>
+                  <a:srgbClr val="2563EB"/>
+                </a:solidFill>
+              </a:defRPr>
+            </a:pPr>
+            <a:r>
+              <a:rPr sz="1050" b="1">
+                <a:latin typeface="HarmonyOS Sans SC" panose="00000500000000000000" charset="-122"/>
+                <a:ea typeface="HarmonyOS Sans SC" panose="00000500000000000000" charset="-122"/>
+                <a:cs typeface="HarmonyOS Sans SC" panose="00000500000000000000" charset="-122"/>
+              </a:rPr>
+              <a:t>结果</a:t>
+            </a:r>
+            <a:endParaRPr sz="1050" b="1">
+              <a:latin typeface="HarmonyOS Sans SC" panose="00000500000000000000" charset="-122"/>
+              <a:ea typeface="HarmonyOS Sans SC" panose="00000500000000000000" charset="-122"/>
+              <a:cs typeface="HarmonyOS Sans SC" panose="00000500000000000000" charset="-122"/>
+            </a:endParaRPr>
+          </a:p>
+          <a:p>
+            <a:pPr algn="r">
+              <a:defRPr sz="1050" b="1">
+                <a:solidFill>
+                  <a:srgbClr val="2563EB"/>
+                </a:solidFill>
+              </a:defRPr>
+            </a:pPr>
+            <a:r>
+              <a:rPr sz="1050" b="1">
+                <a:latin typeface="HarmonyOS Sans SC" panose="00000500000000000000" charset="-122"/>
+                <a:ea typeface="HarmonyOS Sans SC" panose="00000500000000000000" charset="-122"/>
+                <a:cs typeface="HarmonyOS Sans SC" panose="00000500000000000000" charset="-122"/>
+              </a:rPr>
+              <a:t>上传</a:t>
+            </a:r>
+            <a:endParaRPr lang="zh-CN" sz="1050" b="1">
+              <a:solidFill>
+                <a:srgbClr val="7030A0"/>
+              </a:solidFill>
+              <a:latin typeface="HarmonyOS Sans SC" panose="00000500000000000000" charset="-122"/>
+              <a:ea typeface="HarmonyOS Sans SC" panose="00000500000000000000" charset="-122"/>
+              <a:cs typeface="HarmonyOS Sans SC" panose="00000500000000000000" charset="-122"/>
+            </a:endParaRPr>
+          </a:p>
+        </p:txBody>
+      </p:sp>
+      <p:grpSp>
+        <p:nvGrpSpPr>
+          <p:cNvPr id="129" name="组合 128"/>
+          <p:cNvGrpSpPr/>
+          <p:nvPr/>
+        </p:nvGrpSpPr>
+        <p:grpSpPr>
+          <a:xfrm>
+            <a:off x="5048568" y="470535"/>
+            <a:ext cx="1809115" cy="671830"/>
+            <a:chOff x="8013" y="967"/>
+            <a:chExt cx="2849" cy="1058"/>
+          </a:xfrm>
+        </p:grpSpPr>
+        <p:sp>
+          <p:nvSpPr>
+            <p:cNvPr id="113" name="openclaw"/>
+            <p:cNvSpPr>
+              <a:spLocks noGrp="1"/>
+            </p:cNvSpPr>
+            <p:nvPr/>
+          </p:nvSpPr>
+          <p:spPr>
+            <a:xfrm>
+              <a:off x="8013" y="967"/>
+              <a:ext cx="1322" cy="1058"/>
+            </a:xfrm>
+            <a:prstGeom prst="roundRect">
+              <a:avLst>
+                <a:gd name="adj" fmla="val 15789"/>
+              </a:avLst>
+            </a:prstGeom>
+            <a:solidFill>
+              <a:srgbClr val="FCFCFC"/>
+            </a:solidFill>
+            <a:ln w="12383">
+              <a:solidFill>
+                <a:schemeClr val="accent5">
+                  <a:lumMod val="20000"/>
+                  <a:lumOff val="80000"/>
+                </a:schemeClr>
+              </a:solidFill>
+              <a:prstDash val="solid"/>
+            </a:ln>
+          </p:spPr>
+          <p:style>
+            <a:lnRef idx="0">
+              <a:srgbClr val="FFFFFF"/>
+            </a:lnRef>
+            <a:fillRef idx="0">
+              <a:srgbClr val="FFFFFF"/>
+            </a:fillRef>
+            <a:effectRef idx="4">
+              <a:srgbClr val="FFFFFF"/>
+            </a:effectRef>
+            <a:fontRef idx="major"/>
+          </p:style>
+          <p:txBody>
+            <a:bodyPr anchor="ctr" anchorCtr="0"/>
+            <a:lstStyle/>
+            <a:p>
+              <a:pPr algn="ctr">
+                <a:defRPr sz="1500" b="1">
+                  <a:solidFill>
+                    <a:srgbClr val="B45309"/>
+                  </a:solidFill>
+                </a:defRPr>
+              </a:pPr>
+              <a:r>
+                <a:rPr lang="en-US" sz="1200" b="1">
+                  <a:solidFill>
+                    <a:srgbClr val="A778C8"/>
+                  </a:solidFill>
+                  <a:latin typeface="HarmonyOS Sans SC" panose="00000500000000000000" charset="-122"/>
+                  <a:ea typeface="HarmonyOS Sans SC" panose="00000500000000000000" charset="-122"/>
+                  <a:cs typeface="HarmonyOS Sans SC" panose="00000500000000000000" charset="-122"/>
+                </a:rPr>
+                <a:t>QQ</a:t>
+              </a:r>
+              <a:endParaRPr lang="en-US" sz="1200" b="1">
+                <a:solidFill>
+                  <a:srgbClr val="A778C8"/>
+                </a:solidFill>
+                <a:latin typeface="HarmonyOS Sans SC" panose="00000500000000000000" charset="-122"/>
+                <a:ea typeface="HarmonyOS Sans SC" panose="00000500000000000000" charset="-122"/>
+                <a:cs typeface="HarmonyOS Sans SC" panose="00000500000000000000" charset="-122"/>
+              </a:endParaRPr>
+            </a:p>
+            <a:p>
+              <a:pPr algn="ctr">
+                <a:defRPr sz="1500" b="1">
+                  <a:solidFill>
+                    <a:srgbClr val="B45309"/>
+                  </a:solidFill>
+                </a:defRPr>
+              </a:pPr>
+              <a:endParaRPr lang="en-US" sz="1200" b="1">
+                <a:solidFill>
+                  <a:srgbClr val="A778C8"/>
+                </a:solidFill>
+                <a:latin typeface="HarmonyOS Sans SC" panose="00000500000000000000" charset="-122"/>
+                <a:ea typeface="HarmonyOS Sans SC" panose="00000500000000000000" charset="-122"/>
+                <a:cs typeface="HarmonyOS Sans SC" panose="00000500000000000000" charset="-122"/>
+              </a:endParaRPr>
+            </a:p>
+            <a:p>
+              <a:pPr algn="ctr">
+                <a:defRPr sz="1500" b="1">
+                  <a:solidFill>
+                    <a:srgbClr val="B45309"/>
+                  </a:solidFill>
+                </a:defRPr>
+              </a:pPr>
+              <a:endParaRPr lang="en-US" sz="1200" b="1">
+                <a:solidFill>
+                  <a:srgbClr val="A778C8"/>
+                </a:solidFill>
+                <a:latin typeface="HarmonyOS Sans SC" panose="00000500000000000000" charset="-122"/>
+                <a:ea typeface="HarmonyOS Sans SC" panose="00000500000000000000" charset="-122"/>
+                <a:cs typeface="HarmonyOS Sans SC" panose="00000500000000000000" charset="-122"/>
+              </a:endParaRPr>
+            </a:p>
+          </p:txBody>
+        </p:sp>
+        <p:sp>
+          <p:nvSpPr>
+            <p:cNvPr id="115" name="openclaw"/>
+            <p:cNvSpPr>
+              <a:spLocks noGrp="1"/>
+            </p:cNvSpPr>
+            <p:nvPr/>
+          </p:nvSpPr>
+          <p:spPr>
+            <a:xfrm>
+              <a:off x="9514" y="967"/>
+              <a:ext cx="1349" cy="1058"/>
+            </a:xfrm>
+            <a:prstGeom prst="roundRect">
+              <a:avLst>
+                <a:gd name="adj" fmla="val 15789"/>
+              </a:avLst>
+            </a:prstGeom>
+            <a:solidFill>
+              <a:srgbClr val="FCFCFC"/>
+            </a:solidFill>
+            <a:ln w="12383">
+              <a:solidFill>
+                <a:schemeClr val="accent5">
+                  <a:lumMod val="20000"/>
+                  <a:lumOff val="80000"/>
+                </a:schemeClr>
+              </a:solidFill>
+              <a:prstDash val="solid"/>
+            </a:ln>
+          </p:spPr>
+          <p:style>
+            <a:lnRef idx="0">
+              <a:srgbClr val="FFFFFF"/>
+            </a:lnRef>
+            <a:fillRef idx="0">
+              <a:srgbClr val="FFFFFF"/>
+            </a:fillRef>
+            <a:effectRef idx="4">
+              <a:srgbClr val="FFFFFF"/>
+            </a:effectRef>
+            <a:fontRef idx="major"/>
+          </p:style>
+          <p:txBody>
+            <a:bodyPr anchor="ctr" anchorCtr="0"/>
+            <a:lstStyle/>
+            <a:p>
+              <a:pPr algn="ctr">
+                <a:defRPr sz="1500" b="1">
+                  <a:solidFill>
+                    <a:srgbClr val="B45309"/>
+                  </a:solidFill>
+                </a:defRPr>
+              </a:pPr>
+              <a:r>
+                <a:rPr lang="zh-CN" altLang="en-US" sz="1200" b="1">
+                  <a:solidFill>
+                    <a:srgbClr val="A778C8"/>
+                  </a:solidFill>
+                  <a:latin typeface="HarmonyOS Sans SC" panose="00000500000000000000" charset="-122"/>
+                  <a:ea typeface="HarmonyOS Sans SC" panose="00000500000000000000" charset="-122"/>
+                  <a:cs typeface="HarmonyOS Sans SC" panose="00000500000000000000" charset="-122"/>
+                </a:rPr>
+                <a:t>微信</a:t>
+              </a:r>
+              <a:endParaRPr lang="en-US" sz="1200" b="1">
+                <a:solidFill>
+                  <a:srgbClr val="A778C8"/>
+                </a:solidFill>
+                <a:latin typeface="HarmonyOS Sans SC" panose="00000500000000000000" charset="-122"/>
+                <a:ea typeface="HarmonyOS Sans SC" panose="00000500000000000000" charset="-122"/>
+                <a:cs typeface="HarmonyOS Sans SC" panose="00000500000000000000" charset="-122"/>
+              </a:endParaRPr>
+            </a:p>
+            <a:p>
+              <a:pPr algn="ctr">
+                <a:defRPr sz="1500" b="1">
+                  <a:solidFill>
+                    <a:srgbClr val="B45309"/>
+                  </a:solidFill>
+                </a:defRPr>
+              </a:pPr>
+              <a:endParaRPr lang="en-US" sz="1200" b="1">
+                <a:solidFill>
+                  <a:srgbClr val="A778C8"/>
+                </a:solidFill>
+                <a:latin typeface="HarmonyOS Sans SC" panose="00000500000000000000" charset="-122"/>
+                <a:ea typeface="HarmonyOS Sans SC" panose="00000500000000000000" charset="-122"/>
+                <a:cs typeface="HarmonyOS Sans SC" panose="00000500000000000000" charset="-122"/>
+              </a:endParaRPr>
+            </a:p>
+            <a:p>
+              <a:pPr algn="ctr">
+                <a:defRPr sz="1500" b="1">
+                  <a:solidFill>
+                    <a:srgbClr val="B45309"/>
+                  </a:solidFill>
+                </a:defRPr>
+              </a:pPr>
+              <a:endParaRPr lang="en-US" sz="1200" b="1">
+                <a:solidFill>
+                  <a:srgbClr val="A778C8"/>
+                </a:solidFill>
+                <a:latin typeface="HarmonyOS Sans SC" panose="00000500000000000000" charset="-122"/>
+                <a:ea typeface="HarmonyOS Sans SC" panose="00000500000000000000" charset="-122"/>
+                <a:cs typeface="HarmonyOS Sans SC" panose="00000500000000000000" charset="-122"/>
+              </a:endParaRPr>
+            </a:p>
+          </p:txBody>
+        </p:sp>
+      </p:grpSp>
+      <p:pic>
+        <p:nvPicPr>
+          <p:cNvPr id="130" name="图片 129" descr="yJveOJoKqr"/>
+          <p:cNvPicPr>
+            <a:picLocks noChangeAspect="1"/>
+          </p:cNvPicPr>
+          <p:nvPr/>
+        </p:nvPicPr>
+        <p:blipFill>
+          <a:blip r:embed="rId19"/>
+          <a:stretch>
+            <a:fillRect/>
+          </a:stretch>
+        </p:blipFill>
+        <p:spPr>
+          <a:xfrm>
+            <a:off x="6223635" y="686435"/>
+            <a:ext cx="412750" cy="412750"/>
+          </a:xfrm>
+          <a:prstGeom prst="rect">
+            <a:avLst/>
+          </a:prstGeom>
+        </p:spPr>
+      </p:pic>
+      <p:pic>
+        <p:nvPicPr>
+          <p:cNvPr id="131" name="图片 130" descr="553613aef097c96d1631252233"/>
+          <p:cNvPicPr>
+            <a:picLocks noChangeAspect="1"/>
+          </p:cNvPicPr>
+          <p:nvPr/>
+        </p:nvPicPr>
+        <p:blipFill>
+          <a:blip r:embed="rId20">
+            <a:clrChange>
+              <a:clrFrom>
+                <a:srgbClr val="FFFFFF">
+                  <a:alpha val="100000"/>
+                </a:srgbClr>
+              </a:clrFrom>
+              <a:clrTo>
+                <a:srgbClr val="FFFFFF">
+                  <a:alpha val="100000"/>
+                  <a:alpha val="0"/>
+                </a:srgbClr>
+              </a:clrTo>
+            </a:clrChange>
+          </a:blip>
+          <a:stretch>
+            <a:fillRect/>
+          </a:stretch>
+        </p:blipFill>
+        <p:spPr>
+          <a:xfrm>
+            <a:off x="5288915" y="712470"/>
+            <a:ext cx="360000" cy="360000"/>
+          </a:xfrm>
+          <a:prstGeom prst="rect">
+            <a:avLst/>
+          </a:prstGeom>
+        </p:spPr>
+      </p:pic>
+      <p:cxnSp>
+        <p:nvCxnSpPr>
+          <p:cNvPr id="132" name="直接箭头连接符 131"/>
+          <p:cNvCxnSpPr/>
+          <p:nvPr/>
+        </p:nvCxnSpPr>
+        <p:spPr>
+          <a:xfrm>
+            <a:off x="5358765" y="1224915"/>
+            <a:ext cx="0" cy="885825"/>
+          </a:xfrm>
+          <a:prstGeom prst="straightConnector1">
+            <a:avLst/>
+          </a:prstGeom>
+          <a:ln w="23813">
+            <a:solidFill>
+              <a:srgbClr val="ED98E6"/>
+            </a:solidFill>
+            <a:prstDash val="solid"/>
+            <a:headEnd type="none" w="med" len="med"/>
+            <a:tailEnd type="arrow" w="med" len="med"/>
+          </a:ln>
+        </p:spPr>
+      </p:cxnSp>
+      <p:sp>
+        <p:nvSpPr>
+          <p:cNvPr id="133" name="label-Webhook POST"/>
+          <p:cNvSpPr>
+            <a:spLocks noGrp="1"/>
+          </p:cNvSpPr>
+          <p:nvPr/>
+        </p:nvSpPr>
+        <p:spPr>
+          <a:xfrm>
+            <a:off x="4048125" y="1214120"/>
+            <a:ext cx="1310640" cy="324485"/>
+          </a:xfrm>
+          <a:prstGeom prst="roundRect">
+            <a:avLst>
+              <a:gd name="adj" fmla="val 0"/>
+            </a:avLst>
+          </a:prstGeom>
+          <a:noFill/>
+          <a:ln w="7620">
+            <a:noFill/>
+            <a:prstDash val="solid"/>
+          </a:ln>
+          <a:extLst>
+            <a:ext uri="{909E8E84-426E-40DD-AFC4-6F175D3DCCD1}">
+              <a14:hiddenFill xmlns:a14="http://schemas.microsoft.com/office/drawing/2010/main">
+                <a:solidFill>
+                  <a:srgbClr val="FFFFFF"/>
+                </a:solidFill>
+              </a14:hiddenFill>
+            </a:ext>
+          </a:extLst>
+        </p:spPr>
+        <p:txBody>
+          <a:bodyPr anchor="ctr" anchorCtr="0"/>
+          <a:lstStyle/>
+          <a:p>
+            <a:pPr algn="r">
+              <a:defRPr sz="1050" b="1">
+                <a:solidFill>
+                  <a:srgbClr val="C2410C"/>
+                </a:solidFill>
+              </a:defRPr>
+            </a:pPr>
+            <a:r>
+              <a:rPr lang="zh-CN" altLang="en-US" sz="1050" b="1">
+                <a:solidFill>
+                  <a:srgbClr val="C2410C"/>
+                </a:solidFill>
+                <a:latin typeface="HarmonyOS Sans SC" panose="00000500000000000000" charset="-122"/>
+                <a:ea typeface="HarmonyOS Sans SC" panose="00000500000000000000" charset="-122"/>
+              </a:rPr>
+              <a:t>自然语言</a:t>
+            </a:r>
+            <a:r>
+              <a:rPr lang="zh-CN" altLang="en-US" sz="1050" b="1">
+                <a:solidFill>
+                  <a:srgbClr val="C2410C"/>
+                </a:solidFill>
+                <a:latin typeface="HarmonyOS Sans SC" panose="00000500000000000000" charset="-122"/>
+                <a:ea typeface="HarmonyOS Sans SC" panose="00000500000000000000" charset="-122"/>
+              </a:rPr>
+              <a:t>交互</a:t>
+            </a:r>
+            <a:endParaRPr lang="zh-CN" altLang="en-US" sz="1050" b="1">
+              <a:solidFill>
+                <a:srgbClr val="C2410C"/>
+              </a:solidFill>
+              <a:latin typeface="HarmonyOS Sans SC" panose="00000500000000000000" charset="-122"/>
+              <a:ea typeface="HarmonyOS Sans SC" panose="00000500000000000000" charset="-122"/>
+            </a:endParaRPr>
+          </a:p>
+        </p:txBody>
+      </p:sp>
+      <p:cxnSp>
+        <p:nvCxnSpPr>
+          <p:cNvPr id="136" name="直接箭头连接符 135"/>
+          <p:cNvCxnSpPr/>
+          <p:nvPr/>
+        </p:nvCxnSpPr>
+        <p:spPr>
+          <a:xfrm>
+            <a:off x="2066925" y="3981450"/>
+            <a:ext cx="0" cy="417195"/>
+          </a:xfrm>
+          <a:prstGeom prst="straightConnector1">
+            <a:avLst/>
+          </a:prstGeom>
+          <a:ln>
+            <a:solidFill>
+              <a:srgbClr val="0070C0"/>
+            </a:solidFill>
+            <a:tailEnd type="arrow"/>
+          </a:ln>
+        </p:spPr>
+        <p:style>
+          <a:lnRef idx="2">
+            <a:schemeClr val="accent1"/>
+          </a:lnRef>
+          <a:fillRef idx="0">
+            <a:srgbClr val="FFFFFF"/>
+          </a:fillRef>
+          <a:effectRef idx="0">
+            <a:srgbClr val="FFFFFF"/>
+          </a:effectRef>
+          <a:fontRef idx="minor">
+            <a:schemeClr val="tx1"/>
+          </a:fontRef>
+        </p:style>
+      </p:cxnSp>
+      <p:sp>
+        <p:nvSpPr>
+          <p:cNvPr id="137" name="label-日志广播 / 拉取"/>
+          <p:cNvSpPr>
+            <a:spLocks noGrp="1"/>
+          </p:cNvSpPr>
+          <p:nvPr/>
+        </p:nvSpPr>
+        <p:spPr>
+          <a:xfrm>
+            <a:off x="408305" y="4028440"/>
+            <a:ext cx="1658620" cy="323850"/>
+          </a:xfrm>
+          <a:prstGeom prst="roundRect">
+            <a:avLst>
+              <a:gd name="adj" fmla="val 0"/>
+            </a:avLst>
+          </a:prstGeom>
+          <a:noFill/>
+          <a:ln w="7620">
+            <a:noFill/>
+            <a:prstDash val="solid"/>
+          </a:ln>
+          <a:extLst>
+            <a:ext uri="{909E8E84-426E-40DD-AFC4-6F175D3DCCD1}">
+              <a14:hiddenFill xmlns:a14="http://schemas.microsoft.com/office/drawing/2010/main">
+                <a:solidFill>
+                  <a:srgbClr val="FFFFFF"/>
+                </a:solidFill>
+              </a14:hiddenFill>
+            </a:ext>
+          </a:extLst>
+        </p:spPr>
+        <p:txBody>
+          <a:bodyPr anchor="ctr" anchorCtr="0">
+            <a:noAutofit/>
+          </a:bodyPr>
+          <a:lstStyle/>
+          <a:p>
+            <a:pPr lvl="0" algn="r">
+              <a:buClrTx/>
+              <a:buSzTx/>
+              <a:buFontTx/>
+              <a:defRPr sz="1050" b="1">
+                <a:solidFill>
+                  <a:srgbClr val="C2410C"/>
+                </a:solidFill>
+              </a:defRPr>
+            </a:pPr>
+            <a:r>
+              <a:rPr>
+                <a:solidFill>
+                  <a:srgbClr val="2563EB"/>
+                </a:solidFill>
+                <a:latin typeface="HarmonyOS Sans SC" panose="00000500000000000000" charset="-122"/>
+                <a:ea typeface="HarmonyOS Sans SC" panose="00000500000000000000" charset="-122"/>
+                <a:cs typeface="HarmonyOS Sans SC" panose="00000500000000000000" charset="-122"/>
+                <a:sym typeface="+mn-ea"/>
+              </a:rPr>
+              <a:t>Worker start</a:t>
+            </a:r>
+            <a:r>
+              <a:rPr lang="en-US">
+                <a:solidFill>
+                  <a:srgbClr val="2563EB"/>
+                </a:solidFill>
+                <a:latin typeface="HarmonyOS Sans SC" panose="00000500000000000000" charset="-122"/>
+                <a:ea typeface="HarmonyOS Sans SC" panose="00000500000000000000" charset="-122"/>
+                <a:cs typeface="HarmonyOS Sans SC" panose="00000500000000000000" charset="-122"/>
+                <a:sym typeface="+mn-ea"/>
+              </a:rPr>
+              <a:t> </a:t>
+            </a:r>
+            <a:r>
+              <a:rPr>
+                <a:solidFill>
+                  <a:srgbClr val="2563EB"/>
+                </a:solidFill>
+                <a:latin typeface="HarmonyOS Sans SC" panose="00000500000000000000" charset="-122"/>
+                <a:ea typeface="HarmonyOS Sans SC" panose="00000500000000000000" charset="-122"/>
+                <a:cs typeface="HarmonyOS Sans SC" panose="00000500000000000000" charset="-122"/>
+                <a:sym typeface="+mn-ea"/>
+              </a:rPr>
+              <a:t>指令拉起</a:t>
+            </a:r>
+            <a:endParaRPr>
+              <a:solidFill>
+                <a:srgbClr val="2563EB"/>
+              </a:solidFill>
+              <a:latin typeface="HarmonyOS Sans SC" panose="00000500000000000000" charset="-122"/>
+              <a:ea typeface="HarmonyOS Sans SC" panose="00000500000000000000" charset="-122"/>
+              <a:cs typeface="HarmonyOS Sans SC" panose="00000500000000000000" charset="-122"/>
+              <a:sym typeface="+mn-ea"/>
+            </a:endParaRPr>
+          </a:p>
+        </p:txBody>
+      </p:sp>
+      <p:sp>
+        <p:nvSpPr>
+          <p:cNvPr id="138" name="chip-local-worker"/>
+          <p:cNvSpPr>
+            <a:spLocks noGrp="1"/>
+          </p:cNvSpPr>
+          <p:nvPr/>
+        </p:nvSpPr>
+        <p:spPr>
+          <a:xfrm>
+            <a:off x="971550" y="2918460"/>
+            <a:ext cx="2190750" cy="814070"/>
+          </a:xfrm>
+          <a:prstGeom prst="roundRect">
+            <a:avLst>
+              <a:gd name="adj" fmla="val 10374"/>
+            </a:avLst>
+          </a:prstGeom>
+          <a:solidFill>
+            <a:srgbClr val="FFFFFF"/>
+          </a:solidFill>
+          <a:ln w="9525">
+            <a:solidFill>
+              <a:srgbClr val="C6D6F7"/>
+            </a:solidFill>
+            <a:prstDash val="solid"/>
+          </a:ln>
+        </p:spPr>
+        <p:txBody>
+          <a:bodyPr anchor="ctr" anchorCtr="0"/>
+          <a:lstStyle/>
+          <a:p>
+            <a:pPr lvl="0" algn="ctr">
+              <a:buClrTx/>
+              <a:buSzTx/>
+              <a:buFontTx/>
+              <a:defRPr sz="1125" b="0">
+                <a:solidFill>
+                  <a:srgbClr val="172033"/>
+                </a:solidFill>
+              </a:defRPr>
+            </a:pPr>
+            <a:r>
+              <a:rPr>
+                <a:latin typeface="HarmonyOS Sans SC" panose="00000500000000000000" charset="-122"/>
+                <a:ea typeface="HarmonyOS Sans SC" panose="00000500000000000000" charset="-122"/>
+                <a:cs typeface="HarmonyOS Sans SC" panose="00000500000000000000" charset="-122"/>
+                <a:sym typeface="+mn-ea"/>
+              </a:rPr>
+              <a:t>启动 / 暂停 / 检查</a:t>
+            </a:r>
+            <a:endParaRPr>
+              <a:latin typeface="HarmonyOS Sans SC" panose="00000500000000000000" charset="-122"/>
+              <a:ea typeface="HarmonyOS Sans SC" panose="00000500000000000000" charset="-122"/>
+              <a:cs typeface="HarmonyOS Sans SC" panose="00000500000000000000" charset="-122"/>
+              <a:sym typeface="+mn-ea"/>
+            </a:endParaRPr>
+          </a:p>
+          <a:p>
+            <a:pPr lvl="0" algn="ctr">
+              <a:buClrTx/>
+              <a:buSzTx/>
+              <a:buFontTx/>
+              <a:defRPr sz="1125" b="0">
+                <a:solidFill>
+                  <a:srgbClr val="172033"/>
+                </a:solidFill>
+              </a:defRPr>
+            </a:pPr>
+            <a:r>
+              <a:rPr>
+                <a:latin typeface="HarmonyOS Sans SC" panose="00000500000000000000" charset="-122"/>
+                <a:ea typeface="HarmonyOS Sans SC" panose="00000500000000000000" charset="-122"/>
+                <a:cs typeface="HarmonyOS Sans SC" panose="00000500000000000000" charset="-122"/>
+                <a:sym typeface="+mn-ea"/>
+              </a:rPr>
+              <a:t>状态查看 / 日志查看</a:t>
+            </a:r>
+            <a:endParaRPr>
+              <a:latin typeface="HarmonyOS Sans SC" panose="00000500000000000000" charset="-122"/>
+              <a:ea typeface="HarmonyOS Sans SC" panose="00000500000000000000" charset="-122"/>
+              <a:cs typeface="HarmonyOS Sans SC" panose="00000500000000000000" charset="-122"/>
+              <a:sym typeface="+mn-ea"/>
+            </a:endParaRPr>
+          </a:p>
+          <a:p>
+            <a:pPr lvl="0" algn="ctr">
+              <a:buClrTx/>
+              <a:buSzTx/>
+              <a:buFontTx/>
+              <a:defRPr sz="1125" b="0">
+                <a:solidFill>
+                  <a:srgbClr val="172033"/>
+                </a:solidFill>
+              </a:defRPr>
+            </a:pPr>
+            <a:r>
+              <a:rPr>
+                <a:latin typeface="HarmonyOS Sans SC" panose="00000500000000000000" charset="-122"/>
+                <a:ea typeface="HarmonyOS Sans SC" panose="00000500000000000000" charset="-122"/>
+                <a:cs typeface="HarmonyOS Sans SC" panose="00000500000000000000" charset="-122"/>
+                <a:sym typeface="+mn-ea"/>
+              </a:rPr>
+              <a:t>设置编辑 / IPC 访问</a:t>
+            </a:r>
+            <a:endParaRPr sz="1125" b="0">
+              <a:solidFill>
+                <a:srgbClr val="172033"/>
+              </a:solidFill>
+              <a:latin typeface="HarmonyOS Sans SC" panose="00000500000000000000" charset="-122"/>
+              <a:ea typeface="HarmonyOS Sans SC" panose="00000500000000000000" charset="-122"/>
+              <a:cs typeface="HarmonyOS Sans SC" panose="00000500000000000000" charset="-122"/>
+            </a:endParaRPr>
+          </a:p>
+        </p:txBody>
+      </p:sp>
+      <p:sp>
+        <p:nvSpPr>
+          <p:cNvPr id="139" name="chip-local-worker"/>
+          <p:cNvSpPr>
+            <a:spLocks noGrp="1"/>
+          </p:cNvSpPr>
+          <p:nvPr/>
+        </p:nvSpPr>
+        <p:spPr>
+          <a:xfrm>
+            <a:off x="995680" y="6518275"/>
+            <a:ext cx="2190750" cy="711200"/>
+          </a:xfrm>
+          <a:prstGeom prst="roundRect">
+            <a:avLst>
+              <a:gd name="adj" fmla="val 12410"/>
+            </a:avLst>
+          </a:prstGeom>
+          <a:solidFill>
+            <a:srgbClr val="FFFFFF"/>
+          </a:solidFill>
+          <a:ln w="9525">
+            <a:solidFill>
+              <a:srgbClr val="C6D6F7"/>
+            </a:solidFill>
+            <a:prstDash val="solid"/>
+          </a:ln>
+        </p:spPr>
+        <p:txBody>
+          <a:bodyPr anchor="ctr" anchorCtr="0"/>
+          <a:lstStyle/>
+          <a:p>
+            <a:pPr algn="ctr">
+              <a:defRPr sz="1200" b="0">
+                <a:solidFill>
+                  <a:srgbClr val="172033"/>
+                </a:solidFill>
+              </a:defRPr>
+            </a:pPr>
+            <a:r>
+              <a:rPr sz="1125">
+                <a:latin typeface="HarmonyOS Sans SC" panose="00000500000000000000" charset="-122"/>
+                <a:ea typeface="HarmonyOS Sans SC" panose="00000500000000000000" charset="-122"/>
+                <a:cs typeface="HarmonyOS Sans SC" panose="00000500000000000000" charset="-122"/>
+                <a:sym typeface="+mn-ea"/>
+              </a:rPr>
+              <a:t>Windows-only 建模转换</a:t>
+            </a:r>
+            <a:endParaRPr sz="1125" b="0">
+              <a:solidFill>
+                <a:srgbClr val="172033"/>
+              </a:solidFill>
+              <a:latin typeface="HarmonyOS Sans SC" panose="00000500000000000000" charset="-122"/>
+              <a:ea typeface="HarmonyOS Sans SC" panose="00000500000000000000" charset="-122"/>
+              <a:cs typeface="HarmonyOS Sans SC" panose="00000500000000000000" charset="-122"/>
+            </a:endParaRPr>
+          </a:p>
+          <a:p>
+            <a:pPr algn="ctr">
+              <a:defRPr sz="1200" b="0">
+                <a:solidFill>
+                  <a:srgbClr val="172033"/>
+                </a:solidFill>
+              </a:defRPr>
+            </a:pPr>
+            <a:r>
+              <a:rPr sz="1125">
+                <a:latin typeface="HarmonyOS Sans SC" panose="00000500000000000000" charset="-122"/>
+                <a:ea typeface="HarmonyOS Sans SC" panose="00000500000000000000" charset="-122"/>
+                <a:cs typeface="HarmonyOS Sans SC" panose="00000500000000000000" charset="-122"/>
+                <a:sym typeface="+mn-ea"/>
+              </a:rPr>
+              <a:t>注册 / 心跳 / 轮询任务</a:t>
+            </a:r>
+            <a:endParaRPr sz="1125" b="0">
+              <a:solidFill>
+                <a:srgbClr val="172033"/>
+              </a:solidFill>
+              <a:latin typeface="HarmonyOS Sans SC" panose="00000500000000000000" charset="-122"/>
+              <a:ea typeface="HarmonyOS Sans SC" panose="00000500000000000000" charset="-122"/>
+              <a:cs typeface="HarmonyOS Sans SC" panose="00000500000000000000" charset="-122"/>
+            </a:endParaRPr>
+          </a:p>
+          <a:p>
+            <a:pPr algn="ctr">
+              <a:defRPr sz="1200" b="0">
+                <a:solidFill>
+                  <a:srgbClr val="172033"/>
+                </a:solidFill>
+              </a:defRPr>
+            </a:pPr>
+            <a:r>
+              <a:rPr sz="1125">
+                <a:latin typeface="HarmonyOS Sans SC" panose="00000500000000000000" charset="-122"/>
+                <a:ea typeface="HarmonyOS Sans SC" panose="00000500000000000000" charset="-122"/>
+                <a:cs typeface="HarmonyOS Sans SC" panose="00000500000000000000" charset="-122"/>
+                <a:sym typeface="+mn-ea"/>
+              </a:rPr>
+              <a:t>完成后上传 SCDOC</a:t>
+            </a:r>
+            <a:endParaRPr sz="1125" b="0">
+              <a:solidFill>
+                <a:srgbClr val="172033"/>
+              </a:solidFill>
+              <a:latin typeface="HarmonyOS Sans SC" panose="00000500000000000000" charset="-122"/>
+              <a:ea typeface="HarmonyOS Sans SC" panose="00000500000000000000" charset="-122"/>
+              <a:cs typeface="HarmonyOS Sans SC" panose="00000500000000000000" charset="-122"/>
+            </a:endParaRPr>
+          </a:p>
+        </p:txBody>
+      </p:sp>
+      <p:cxnSp>
+        <p:nvCxnSpPr>
+          <p:cNvPr id="141" name="直接连接符 140"/>
+          <p:cNvCxnSpPr/>
+          <p:nvPr/>
+        </p:nvCxnSpPr>
+        <p:spPr>
+          <a:xfrm>
+            <a:off x="269240" y="3076575"/>
+            <a:ext cx="454660" cy="0"/>
+          </a:xfrm>
+          <a:prstGeom prst="line">
+            <a:avLst/>
+          </a:prstGeom>
+          <a:ln>
+            <a:solidFill>
+              <a:srgbClr val="0070C0"/>
+            </a:solidFill>
+          </a:ln>
+        </p:spPr>
+        <p:style>
+          <a:lnRef idx="2">
+            <a:schemeClr val="accent1"/>
+          </a:lnRef>
+          <a:fillRef idx="0">
+            <a:srgbClr val="FFFFFF"/>
+          </a:fillRef>
+          <a:effectRef idx="0">
+            <a:srgbClr val="FFFFFF"/>
+          </a:effectRef>
+          <a:fontRef idx="minor">
+            <a:schemeClr val="tx1"/>
+          </a:fontRef>
+        </p:style>
+      </p:cxnSp>
+      <p:cxnSp>
+        <p:nvCxnSpPr>
+          <p:cNvPr id="142" name="直接连接符 141"/>
+          <p:cNvCxnSpPr/>
+          <p:nvPr/>
+        </p:nvCxnSpPr>
+        <p:spPr>
+          <a:xfrm>
+            <a:off x="274955" y="3076575"/>
+            <a:ext cx="0" cy="4772025"/>
+          </a:xfrm>
+          <a:prstGeom prst="line">
+            <a:avLst/>
+          </a:prstGeom>
+          <a:ln>
+            <a:solidFill>
+              <a:srgbClr val="0070C0"/>
+            </a:solidFill>
+          </a:ln>
+        </p:spPr>
+        <p:style>
+          <a:lnRef idx="2">
+            <a:schemeClr val="accent1"/>
+          </a:lnRef>
+          <a:fillRef idx="0">
+            <a:srgbClr val="FFFFFF"/>
+          </a:fillRef>
+          <a:effectRef idx="0">
+            <a:srgbClr val="FFFFFF"/>
+          </a:effectRef>
+          <a:fontRef idx="minor">
+            <a:schemeClr val="tx1"/>
+          </a:fontRef>
+        </p:style>
+      </p:cxnSp>
+      <p:cxnSp>
+        <p:nvCxnSpPr>
+          <p:cNvPr id="143" name="直接连接符 142"/>
+          <p:cNvCxnSpPr/>
+          <p:nvPr/>
+        </p:nvCxnSpPr>
+        <p:spPr>
+          <a:xfrm>
+            <a:off x="266065" y="7848600"/>
+            <a:ext cx="7781290" cy="0"/>
+          </a:xfrm>
+          <a:prstGeom prst="line">
+            <a:avLst/>
+          </a:prstGeom>
+          <a:ln>
+            <a:solidFill>
+              <a:srgbClr val="0070C0"/>
+            </a:solidFill>
+          </a:ln>
+        </p:spPr>
+        <p:style>
+          <a:lnRef idx="2">
+            <a:schemeClr val="accent1"/>
+          </a:lnRef>
+          <a:fillRef idx="0">
+            <a:srgbClr val="FFFFFF"/>
+          </a:fillRef>
+          <a:effectRef idx="0">
+            <a:srgbClr val="FFFFFF"/>
+          </a:effectRef>
+          <a:fontRef idx="minor">
+            <a:schemeClr val="tx1"/>
+          </a:fontRef>
+        </p:style>
+      </p:cxnSp>
+      <p:cxnSp>
+        <p:nvCxnSpPr>
+          <p:cNvPr id="145" name="直接连接符 144"/>
+          <p:cNvCxnSpPr/>
+          <p:nvPr/>
+        </p:nvCxnSpPr>
+        <p:spPr>
+          <a:xfrm>
+            <a:off x="8052435" y="7093585"/>
+            <a:ext cx="0" cy="755015"/>
+          </a:xfrm>
+          <a:prstGeom prst="line">
+            <a:avLst/>
+          </a:prstGeom>
+          <a:ln>
+            <a:solidFill>
+              <a:srgbClr val="0070C0"/>
+            </a:solidFill>
+          </a:ln>
+        </p:spPr>
+        <p:style>
+          <a:lnRef idx="2">
+            <a:schemeClr val="accent1"/>
+          </a:lnRef>
+          <a:fillRef idx="0">
+            <a:srgbClr val="FFFFFF"/>
+          </a:fillRef>
+          <a:effectRef idx="0">
+            <a:srgbClr val="FFFFFF"/>
+          </a:effectRef>
+          <a:fontRef idx="minor">
+            <a:schemeClr val="tx1"/>
+          </a:fontRef>
+        </p:style>
+      </p:cxnSp>
+      <p:cxnSp>
+        <p:nvCxnSpPr>
+          <p:cNvPr id="146" name="直接箭头连接符 145"/>
+          <p:cNvCxnSpPr/>
+          <p:nvPr/>
+        </p:nvCxnSpPr>
+        <p:spPr>
+          <a:xfrm>
+            <a:off x="8052435" y="7094220"/>
+            <a:ext cx="196215" cy="0"/>
+          </a:xfrm>
+          <a:prstGeom prst="straightConnector1">
+            <a:avLst/>
+          </a:prstGeom>
+          <a:ln>
+            <a:solidFill>
+              <a:srgbClr val="0070C0"/>
+            </a:solidFill>
+            <a:tailEnd type="arrow"/>
+          </a:ln>
+        </p:spPr>
+        <p:style>
+          <a:lnRef idx="2">
+            <a:schemeClr val="accent1"/>
+          </a:lnRef>
+          <a:fillRef idx="0">
+            <a:srgbClr val="FFFFFF"/>
+          </a:fillRef>
+          <a:effectRef idx="0">
+            <a:srgbClr val="FFFFFF"/>
+          </a:effectRef>
+          <a:fontRef idx="minor">
+            <a:schemeClr val="tx1"/>
+          </a:fontRef>
+        </p:style>
+      </p:cxnSp>
+      <p:sp>
+        <p:nvSpPr>
+          <p:cNvPr id="147" name="label-SSH 本地端口转发 /"/>
+          <p:cNvSpPr>
+            <a:spLocks noGrp="1"/>
+          </p:cNvSpPr>
+          <p:nvPr/>
+        </p:nvSpPr>
+        <p:spPr>
+          <a:xfrm>
+            <a:off x="8052435" y="7693660"/>
+            <a:ext cx="1962150" cy="323850"/>
+          </a:xfrm>
+          <a:prstGeom prst="roundRect">
+            <a:avLst>
+              <a:gd name="adj" fmla="val 0"/>
+            </a:avLst>
+          </a:prstGeom>
+          <a:noFill/>
+          <a:ln w="7620">
+            <a:noFill/>
+            <a:prstDash val="solid"/>
+          </a:ln>
+          <a:extLst>
+            <a:ext uri="{909E8E84-426E-40DD-AFC4-6F175D3DCCD1}">
+              <a14:hiddenFill xmlns:a14="http://schemas.microsoft.com/office/drawing/2010/main">
+                <a:solidFill>
+                  <a:srgbClr val="FFFFFF"/>
+                </a:solidFill>
+              </a14:hiddenFill>
+            </a:ext>
+          </a:extLst>
+        </p:spPr>
+        <p:txBody>
+          <a:bodyPr anchor="ctr" anchorCtr="0"/>
+          <a:lstStyle/>
+          <a:p>
+            <a:pPr algn="l">
+              <a:defRPr sz="1050" b="1">
+                <a:solidFill>
+                  <a:srgbClr val="2563EB"/>
+                </a:solidFill>
+              </a:defRPr>
+            </a:pPr>
+            <a:r>
+              <a:rPr lang="zh-CN" sz="1050" b="1">
+                <a:solidFill>
+                  <a:srgbClr val="2563EB"/>
+                </a:solidFill>
+                <a:latin typeface="HarmonyOS Sans SC" panose="00000500000000000000" charset="-122"/>
+                <a:ea typeface="HarmonyOS Sans SC" panose="00000500000000000000" charset="-122"/>
+                <a:cs typeface="HarmonyOS Sans SC" panose="00000500000000000000" charset="-122"/>
+              </a:rPr>
+              <a:t>组件拉起</a:t>
+            </a:r>
+            <a:endParaRPr lang="zh-CN" sz="1050" b="1">
+              <a:solidFill>
+                <a:srgbClr val="2563EB"/>
+              </a:solidFill>
+              <a:latin typeface="HarmonyOS Sans SC" panose="00000500000000000000" charset="-122"/>
+              <a:ea typeface="HarmonyOS Sans SC" panose="00000500000000000000" charset="-122"/>
+              <a:cs typeface="HarmonyOS Sans SC" panose="00000500000000000000" charset="-122"/>
+            </a:endParaRPr>
+          </a:p>
+        </p:txBody>
+      </p:sp>
     </p:spTree>
   </p:cSld>
   <p:clrMapOvr>

</xml_diff>